<commit_message>
Complete verified step visuals and guides for Lab 07
</commit_message>
<xml_diff>
--- a/slides/LAB07_RLS_pgvector_Bukti_Live.pptx
+++ b/slides/LAB07_RLS_pgvector_Bukti_Live.pptx
@@ -26,7 +26,10 @@
     <p:sldId id="303" r:id="rId17"/>
     <p:sldId id="304" r:id="rId18"/>
     <p:sldId id="305" r:id="rId19"/>
+    <p:sldId id="307" r:id="rId26"/>
     <p:sldId id="306" r:id="rId20"/>
+    <p:sldId id="308" r:id="rId27"/>
+    <p:sldId id="309" r:id="rId28"/>
   </p:sldIdLst>
   <p:sldSz cx="12192000" cy="6858000"/>
   <p:notesSz cx="6858000" cy="12192000"/>
@@ -500,6 +503,81 @@
         <p14:creationId xmlns:p14="http://schemas.microsoft.com/office/powerpoint/2010/main" val="1024086991"/>
       </p:ext>
     </p:extLst>
+  </p:cSld>
+  <p:clrMapOvr>
+    <a:masterClrMapping/>
+  </p:clrMapOvr>
+</p:notes>
+</file>
+
+<file path=ppt/notesSlides/notesSlide12.xml><?xml version="1.0" encoding="utf-8"?>
+<p:notes xmlns:a="http://schemas.openxmlformats.org/drawingml/2006/main" xmlns:p="http://schemas.openxmlformats.org/presentationml/2006/main" xmlns:r="http://schemas.openxmlformats.org/officeDocument/2006/relationships">
+  <p:cSld>
+    <p:spTree>
+      <p:nvGrpSpPr>
+        <p:cNvPr id="1" name=""/>
+        <p:cNvGrpSpPr/>
+        <p:nvPr/>
+      </p:nvGrpSpPr>
+      <p:grpSpPr>
+        <a:xfrm>
+          <a:off x="0" y="0"/>
+          <a:ext cx="0" cy="0"/>
+          <a:chOff x="0" y="0"/>
+          <a:chExt cx="0" cy="0"/>
+        </a:xfrm>
+      </p:grpSpPr>
+    </p:spTree>
+  </p:cSld>
+  <p:clrMapOvr>
+    <a:masterClrMapping/>
+  </p:clrMapOvr>
+</p:notes>
+</file>
+
+<file path=ppt/notesSlides/notesSlide13.xml><?xml version="1.0" encoding="utf-8"?>
+<p:notes xmlns:a="http://schemas.openxmlformats.org/drawingml/2006/main" xmlns:p="http://schemas.openxmlformats.org/presentationml/2006/main" xmlns:r="http://schemas.openxmlformats.org/officeDocument/2006/relationships">
+  <p:cSld>
+    <p:spTree>
+      <p:nvGrpSpPr>
+        <p:cNvPr id="1" name=""/>
+        <p:cNvGrpSpPr/>
+        <p:nvPr/>
+      </p:nvGrpSpPr>
+      <p:grpSpPr>
+        <a:xfrm>
+          <a:off x="0" y="0"/>
+          <a:ext cx="0" cy="0"/>
+          <a:chOff x="0" y="0"/>
+          <a:chExt cx="0" cy="0"/>
+        </a:xfrm>
+      </p:grpSpPr>
+    </p:spTree>
+  </p:cSld>
+  <p:clrMapOvr>
+    <a:masterClrMapping/>
+  </p:clrMapOvr>
+</p:notes>
+</file>
+
+<file path=ppt/notesSlides/notesSlide14.xml><?xml version="1.0" encoding="utf-8"?>
+<p:notes xmlns:a="http://schemas.openxmlformats.org/drawingml/2006/main" xmlns:p="http://schemas.openxmlformats.org/presentationml/2006/main" xmlns:r="http://schemas.openxmlformats.org/officeDocument/2006/relationships">
+  <p:cSld>
+    <p:spTree>
+      <p:nvGrpSpPr>
+        <p:cNvPr id="1" name=""/>
+        <p:cNvGrpSpPr/>
+        <p:nvPr/>
+      </p:nvGrpSpPr>
+      <p:grpSpPr>
+        <a:xfrm>
+          <a:off x="0" y="0"/>
+          <a:ext cx="0" cy="0"/>
+          <a:chOff x="0" y="0"/>
+          <a:chExt cx="0" cy="0"/>
+        </a:xfrm>
+      </p:grpSpPr>
+    </p:spTree>
   </p:cSld>
   <p:clrMapOvr>
     <a:masterClrMapping/>
@@ -7849,7 +7927,7 @@
                 <a:ea typeface="Calibri" pitchFamily="34" charset="-122"/>
                 <a:cs typeface="Calibri" pitchFamily="34" charset="-120"/>
               </a:rPr>
-              <a:t>19</a:t>
+              <a:t>20</a:t>
             </a:r>
             <a:endParaRPr lang="en-US" sz="900" dirty="0"/>
           </a:p>
@@ -9335,6 +9413,1008 @@
         <p14:creationId xmlns:p14="http://schemas.microsoft.com/office/powerpoint/2010/main" val="18459085"/>
       </p:ext>
     </p:extLst>
+  </p:cSld>
+  <p:clrMapOvr>
+    <a:masterClrMapping/>
+  </p:clrMapOvr>
+</p:sld>
+</file>
+
+<file path=ppt/slides/slide20.xml><?xml version="1.0" encoding="utf-8"?>
+<p:sld xmlns:a="http://schemas.openxmlformats.org/drawingml/2006/main" xmlns:p="http://schemas.openxmlformats.org/presentationml/2006/main" xmlns:r="http://schemas.openxmlformats.org/officeDocument/2006/relationships">
+  <p:cSld>
+    <p:spTree>
+      <p:nvGrpSpPr>
+        <p:cNvPr id="1" name=""/>
+        <p:cNvGrpSpPr/>
+        <p:nvPr/>
+      </p:nvGrpSpPr>
+      <p:grpSpPr/>
+      <p:sp>
+        <p:nvSpPr>
+          <p:cNvPr id="2" name="Text 0"/>
+          <p:cNvSpPr/>
+          <p:nvPr/>
+        </p:nvSpPr>
+        <p:spPr>
+          <a:xfrm>
+            <a:off x="457200" y="6492240"/>
+            <a:ext cx="7315200" cy="274320"/>
+          </a:xfrm>
+          <a:prstGeom prst="rect">
+            <a:avLst/>
+          </a:prstGeom>
+          <a:noFill/>
+          <a:ln/>
+        </p:spPr>
+        <p:txBody>
+          <a:bodyPr wrap="square" lIns="0" tIns="0" rIns="0" bIns="0" rtlCol="0" anchor="ctr"/>
+          <a:lstStyle/>
+          <a:p>
+            <a:pPr marL="0" indent="0" algn="l">
+              <a:buNone/>
+            </a:pPr>
+            <a:r>
+              <a:rPr lang="en-US" sz="900" dirty="0">
+                <a:solidFill>
+                  <a:srgbClr val="64748B"/>
+                </a:solidFill>
+                <a:latin typeface="Calibri" pitchFamily="34" charset="0"/>
+                <a:ea typeface="Calibri" pitchFamily="34" charset="-122"/>
+                <a:cs typeface="Calibri" pitchFamily="34" charset="-120"/>
+              </a:rPr>
+              <a:t>BINUS UNIVERSITY  |  Cloud Services  |  Praktikum 7</a:t>
+            </a:r>
+            <a:endParaRPr lang="en-US" sz="900" dirty="0"/>
+          </a:p>
+        </p:txBody>
+      </p:sp>
+      <p:sp>
+        <p:nvSpPr>
+          <p:cNvPr id="3" name="Text 1"/>
+          <p:cNvSpPr/>
+          <p:nvPr/>
+        </p:nvSpPr>
+        <p:spPr>
+          <a:xfrm>
+            <a:off x="11247120" y="6492240"/>
+            <a:ext cx="457200" cy="274320"/>
+          </a:xfrm>
+          <a:prstGeom prst="rect">
+            <a:avLst/>
+          </a:prstGeom>
+          <a:noFill/>
+          <a:ln/>
+        </p:spPr>
+        <p:txBody>
+          <a:bodyPr wrap="square" lIns="0" tIns="0" rIns="0" bIns="0" rtlCol="0" anchor="ctr"/>
+          <a:lstStyle/>
+          <a:p>
+            <a:pPr marL="0" indent="0" algn="r">
+              <a:buNone/>
+            </a:pPr>
+            <a:r>
+              <a:rPr lang="en-US" sz="900" b="1">
+                <a:solidFill>
+                  <a:srgbClr val="64748B"/>
+                </a:solidFill>
+                <a:latin typeface="Calibri" pitchFamily="34" charset="0"/>
+                <a:ea typeface="Calibri" pitchFamily="34" charset="-122"/>
+                <a:cs typeface="Calibri" pitchFamily="34" charset="-120"/>
+              </a:rPr>
+              <a:t>19</a:t>
+            </a:r>
+            <a:endParaRPr lang="en-US" sz="900" dirty="0"/>
+          </a:p>
+        </p:txBody>
+      </p:sp>
+      <p:sp>
+        <p:nvSpPr>
+          <p:cNvPr id="4" name="Shape 2"/>
+          <p:cNvSpPr/>
+          <p:nvPr/>
+        </p:nvSpPr>
+        <p:spPr>
+          <a:xfrm>
+            <a:off x="457200" y="6446520"/>
+            <a:ext cx="228600" cy="36576"/>
+          </a:xfrm>
+          <a:prstGeom prst="rect">
+            <a:avLst/>
+          </a:prstGeom>
+          <a:solidFill>
+            <a:srgbClr val="F37021"/>
+          </a:solidFill>
+          <a:ln w="12700">
+            <a:solidFill>
+              <a:srgbClr val="F37021"/>
+            </a:solidFill>
+            <a:prstDash val="solid"/>
+          </a:ln>
+        </p:spPr>
+      </p:sp>
+      <p:pic>
+        <p:nvPicPr>
+          <p:cNvPr id="5" name="Picture 4" descr="image.png"/>
+          <p:cNvPicPr>
+            <a:picLocks noChangeAspect="1"/>
+          </p:cNvPicPr>
+          <p:nvPr/>
+        </p:nvPicPr>
+        <p:blipFill>
+          <a:blip r:embed="rId2"/>
+          <a:stretch>
+            <a:fillRect/>
+          </a:stretch>
+        </p:blipFill>
+        <p:spPr>
+          <a:xfrm>
+            <a:off x="274320" y="164592"/>
+            <a:ext cx="914400" cy="603504"/>
+          </a:xfrm>
+          <a:prstGeom prst="rect">
+            <a:avLst/>
+          </a:prstGeom>
+        </p:spPr>
+      </p:pic>
+      <p:pic>
+        <p:nvPicPr>
+          <p:cNvPr id="6" name="Picture 5" descr="image.png"/>
+          <p:cNvPicPr>
+            <a:picLocks noChangeAspect="1"/>
+          </p:cNvPicPr>
+          <p:nvPr/>
+        </p:nvPicPr>
+        <p:blipFill>
+          <a:blip r:embed="rId3"/>
+          <a:stretch>
+            <a:fillRect/>
+          </a:stretch>
+        </p:blipFill>
+        <p:spPr>
+          <a:xfrm>
+            <a:off x="10881360" y="182880"/>
+            <a:ext cx="1005840" cy="512064"/>
+          </a:xfrm>
+          <a:prstGeom prst="rect">
+            <a:avLst/>
+          </a:prstGeom>
+        </p:spPr>
+      </p:pic>
+      <p:sp>
+        <p:nvSpPr>
+          <p:cNvPr id="7" name="Shape 3"/>
+          <p:cNvSpPr/>
+          <p:nvPr/>
+        </p:nvSpPr>
+        <p:spPr>
+          <a:xfrm>
+            <a:off x="457200" y="868680"/>
+            <a:ext cx="11247120" cy="0"/>
+          </a:xfrm>
+          <a:prstGeom prst="line">
+            <a:avLst/>
+          </a:prstGeom>
+          <a:noFill/>
+          <a:ln w="12700">
+            <a:solidFill>
+              <a:srgbClr val="E2E8F0"/>
+            </a:solidFill>
+            <a:prstDash val="solid"/>
+          </a:ln>
+        </p:spPr>
+      </p:sp>
+      <p:sp>
+        <p:nvSpPr>
+          <p:cNvPr id="8" name="Text 4"/>
+          <p:cNvSpPr/>
+          <p:nvPr/>
+        </p:nvSpPr>
+        <p:spPr>
+          <a:xfrm>
+            <a:off x="2011680" y="182880"/>
+            <a:ext cx="8138160" cy="502920"/>
+          </a:xfrm>
+          <a:prstGeom prst="rect">
+            <a:avLst/>
+          </a:prstGeom>
+          <a:noFill/>
+          <a:ln/>
+        </p:spPr>
+        <p:txBody>
+          <a:bodyPr wrap="square" lIns="0" tIns="0" rIns="0" bIns="0" rtlCol="0" anchor="ctr"/>
+          <a:lstStyle/>
+          <a:p>
+            <a:pPr marL="0" indent="0" algn="ctr">
+              <a:buNone/>
+            </a:pPr>
+            <a:r>
+              <a:rPr lang="en-US" sz="2200" b="1">
+                <a:solidFill>
+                  <a:srgbClr val="1976D2"/>
+                </a:solidFill>
+                <a:latin typeface="Calibri" pitchFamily="34" charset="0"/>
+                <a:ea typeface="Calibri" pitchFamily="34" charset="-122"/>
+                <a:cs typeface="Calibri" pitchFamily="34" charset="-120"/>
+              </a:rPr>
+              <a:t>Bukti 8 | Source jalur Supabase</a:t>
+            </a:r>
+            <a:endParaRPr lang="en-US" sz="2200" dirty="0"/>
+          </a:p>
+        </p:txBody>
+      </p:sp>
+      <p:sp>
+        <p:nvSpPr>
+          <p:cNvPr id="9" name="Text 5"/>
+          <p:cNvSpPr/>
+          <p:nvPr/>
+        </p:nvSpPr>
+        <p:spPr>
+          <a:xfrm>
+            <a:off x="457200" y="960120"/>
+            <a:ext cx="11247120" cy="320040"/>
+          </a:xfrm>
+          <a:prstGeom prst="rect">
+            <a:avLst/>
+          </a:prstGeom>
+          <a:noFill/>
+          <a:ln/>
+        </p:spPr>
+        <p:txBody>
+          <a:bodyPr wrap="square" lIns="0" tIns="0" rIns="0" bIns="0" rtlCol="0" anchor="ctr"/>
+          <a:lstStyle/>
+          <a:p>
+            <a:pPr marL="0" indent="0" algn="ctr">
+              <a:buNone/>
+            </a:pPr>
+            <a:r>
+              <a:rPr lang="es-ES" sz="1200" i="1">
+                <a:solidFill>
+                  <a:srgbClr val="64748B"/>
+                </a:solidFill>
+                <a:latin typeface="Calibri" pitchFamily="34" charset="0"/>
+                <a:ea typeface="Calibri" pitchFamily="34" charset="-122"/>
+                <a:cs typeface="Calibri" pitchFamily="34" charset="-120"/>
+              </a:rPr>
+              <a:t>Persiapan SQL cloud, belum eksekusi proyek peserta</a:t>
+            </a:r>
+            <a:endParaRPr lang="en-US" sz="1200" dirty="0"/>
+          </a:p>
+        </p:txBody>
+      </p:sp>
+      <p:pic>
+        <p:nvPicPr>
+          <p:cNvPr id="10" name="Picture 9" descr="13_supabase_source.png"/>
+          <p:cNvPicPr>
+            <a:picLocks noChangeAspect="1"/>
+          </p:cNvPicPr>
+          <p:nvPr/>
+        </p:nvPicPr>
+        <p:blipFill>
+          <a:blip r:embed="rId4"/>
+          <a:stretch>
+            <a:fillRect/>
+          </a:stretch>
+        </p:blipFill>
+        <p:spPr>
+          <a:xfrm>
+            <a:off x="1304963" y="1463040"/>
+            <a:ext cx="9597314" cy="4343400"/>
+          </a:xfrm>
+          <a:prstGeom prst="rect">
+            <a:avLst/>
+          </a:prstGeom>
+        </p:spPr>
+      </p:pic>
+      <p:sp>
+        <p:nvSpPr>
+          <p:cNvPr id="11" name="TextBox 10"/>
+          <p:cNvSpPr txBox="1"/>
+          <p:nvPr/>
+        </p:nvSpPr>
+        <p:spPr>
+          <a:xfrm>
+            <a:off x="685800" y="5797296"/>
+            <a:ext cx="10881360" cy="566928"/>
+          </a:xfrm>
+          <a:prstGeom prst="rect">
+            <a:avLst/>
+          </a:prstGeom>
+          <a:noFill/>
+        </p:spPr>
+        <p:txBody>
+          <a:bodyPr wrap="square">
+            <a:spAutoFit/>
+          </a:bodyPr>
+          <a:lstStyle/>
+          <a:p>
+            <a:pPr>
+              <a:defRPr sz="1400">
+                <a:solidFill>
+                  <a:srgbClr val="0F336F"/>
+                </a:solidFill>
+                <a:latin typeface="Arial"/>
+              </a:defRPr>
+            </a:pPr>
+            <a:r>
+              <a:t>Perintah: rg -n pada schema.sql. Fungsi: kenali policy cloud.</a:t>
+            </a:r>
+            <a:br/>
+            <a:r>
+              <a:t>Cara kerja: hanya membaca source; hasil: auth.users/auth.uid(), belum dieksekusi di cloud.</a:t>
+            </a:r>
+          </a:p>
+        </p:txBody>
+      </p:sp>
+    </p:spTree>
+  </p:cSld>
+  <p:clrMapOvr>
+    <a:masterClrMapping/>
+  </p:clrMapOvr>
+</p:sld>
+</file>
+
+<file path=ppt/slides/slide21.xml><?xml version="1.0" encoding="utf-8"?>
+<p:sld xmlns:a="http://schemas.openxmlformats.org/drawingml/2006/main" xmlns:p="http://schemas.openxmlformats.org/presentationml/2006/main" xmlns:r="http://schemas.openxmlformats.org/officeDocument/2006/relationships">
+  <p:cSld>
+    <p:spTree>
+      <p:nvGrpSpPr>
+        <p:cNvPr id="1" name=""/>
+        <p:cNvGrpSpPr/>
+        <p:nvPr/>
+      </p:nvGrpSpPr>
+      <p:grpSpPr/>
+      <p:sp>
+        <p:nvSpPr>
+          <p:cNvPr id="2" name="Text 0"/>
+          <p:cNvSpPr/>
+          <p:nvPr/>
+        </p:nvSpPr>
+        <p:spPr>
+          <a:xfrm>
+            <a:off x="457200" y="6492240"/>
+            <a:ext cx="7315200" cy="274320"/>
+          </a:xfrm>
+          <a:prstGeom prst="rect">
+            <a:avLst/>
+          </a:prstGeom>
+          <a:noFill/>
+          <a:ln/>
+        </p:spPr>
+        <p:txBody>
+          <a:bodyPr wrap="square" lIns="0" tIns="0" rIns="0" bIns="0" rtlCol="0" anchor="ctr"/>
+          <a:lstStyle/>
+          <a:p>
+            <a:pPr marL="0" indent="0" algn="l">
+              <a:buNone/>
+            </a:pPr>
+            <a:r>
+              <a:rPr lang="en-US" sz="900" dirty="0">
+                <a:solidFill>
+                  <a:srgbClr val="64748B"/>
+                </a:solidFill>
+                <a:latin typeface="Calibri" pitchFamily="34" charset="0"/>
+                <a:ea typeface="Calibri" pitchFamily="34" charset="-122"/>
+                <a:cs typeface="Calibri" pitchFamily="34" charset="-120"/>
+              </a:rPr>
+              <a:t>BINUS UNIVERSITY  |  Cloud Services  |  Praktikum 7</a:t>
+            </a:r>
+            <a:endParaRPr lang="en-US" sz="900" dirty="0"/>
+          </a:p>
+        </p:txBody>
+      </p:sp>
+      <p:sp>
+        <p:nvSpPr>
+          <p:cNvPr id="3" name="Text 1"/>
+          <p:cNvSpPr/>
+          <p:nvPr/>
+        </p:nvSpPr>
+        <p:spPr>
+          <a:xfrm>
+            <a:off x="11247120" y="6492240"/>
+            <a:ext cx="457200" cy="274320"/>
+          </a:xfrm>
+          <a:prstGeom prst="rect">
+            <a:avLst/>
+          </a:prstGeom>
+          <a:noFill/>
+          <a:ln/>
+        </p:spPr>
+        <p:txBody>
+          <a:bodyPr wrap="square" lIns="0" tIns="0" rIns="0" bIns="0" rtlCol="0" anchor="ctr"/>
+          <a:lstStyle/>
+          <a:p>
+            <a:pPr marL="0" indent="0" algn="r">
+              <a:buNone/>
+            </a:pPr>
+            <a:r>
+              <a:rPr lang="en-US" sz="900" b="1">
+                <a:solidFill>
+                  <a:srgbClr val="64748B"/>
+                </a:solidFill>
+                <a:latin typeface="Calibri" pitchFamily="34" charset="0"/>
+                <a:ea typeface="Calibri" pitchFamily="34" charset="-122"/>
+                <a:cs typeface="Calibri" pitchFamily="34" charset="-120"/>
+              </a:rPr>
+              <a:t>21</a:t>
+            </a:r>
+            <a:endParaRPr lang="en-US" sz="900" dirty="0"/>
+          </a:p>
+        </p:txBody>
+      </p:sp>
+      <p:sp>
+        <p:nvSpPr>
+          <p:cNvPr id="4" name="Shape 2"/>
+          <p:cNvSpPr/>
+          <p:nvPr/>
+        </p:nvSpPr>
+        <p:spPr>
+          <a:xfrm>
+            <a:off x="457200" y="6446520"/>
+            <a:ext cx="228600" cy="36576"/>
+          </a:xfrm>
+          <a:prstGeom prst="rect">
+            <a:avLst/>
+          </a:prstGeom>
+          <a:solidFill>
+            <a:srgbClr val="F37021"/>
+          </a:solidFill>
+          <a:ln w="12700">
+            <a:solidFill>
+              <a:srgbClr val="F37021"/>
+            </a:solidFill>
+            <a:prstDash val="solid"/>
+          </a:ln>
+        </p:spPr>
+      </p:sp>
+      <p:pic>
+        <p:nvPicPr>
+          <p:cNvPr id="5" name="Picture 4" descr="image.png"/>
+          <p:cNvPicPr>
+            <a:picLocks noChangeAspect="1"/>
+          </p:cNvPicPr>
+          <p:nvPr/>
+        </p:nvPicPr>
+        <p:blipFill>
+          <a:blip r:embed="rId2"/>
+          <a:stretch>
+            <a:fillRect/>
+          </a:stretch>
+        </p:blipFill>
+        <p:spPr>
+          <a:xfrm>
+            <a:off x="274320" y="164592"/>
+            <a:ext cx="914400" cy="603504"/>
+          </a:xfrm>
+          <a:prstGeom prst="rect">
+            <a:avLst/>
+          </a:prstGeom>
+        </p:spPr>
+      </p:pic>
+      <p:pic>
+        <p:nvPicPr>
+          <p:cNvPr id="6" name="Picture 5" descr="image.png"/>
+          <p:cNvPicPr>
+            <a:picLocks noChangeAspect="1"/>
+          </p:cNvPicPr>
+          <p:nvPr/>
+        </p:nvPicPr>
+        <p:blipFill>
+          <a:blip r:embed="rId3"/>
+          <a:stretch>
+            <a:fillRect/>
+          </a:stretch>
+        </p:blipFill>
+        <p:spPr>
+          <a:xfrm>
+            <a:off x="10881360" y="182880"/>
+            <a:ext cx="1005840" cy="512064"/>
+          </a:xfrm>
+          <a:prstGeom prst="rect">
+            <a:avLst/>
+          </a:prstGeom>
+        </p:spPr>
+      </p:pic>
+      <p:sp>
+        <p:nvSpPr>
+          <p:cNvPr id="7" name="Shape 3"/>
+          <p:cNvSpPr/>
+          <p:nvPr/>
+        </p:nvSpPr>
+        <p:spPr>
+          <a:xfrm>
+            <a:off x="457200" y="868680"/>
+            <a:ext cx="11247120" cy="0"/>
+          </a:xfrm>
+          <a:prstGeom prst="line">
+            <a:avLst/>
+          </a:prstGeom>
+          <a:noFill/>
+          <a:ln w="12700">
+            <a:solidFill>
+              <a:srgbClr val="E2E8F0"/>
+            </a:solidFill>
+            <a:prstDash val="solid"/>
+          </a:ln>
+        </p:spPr>
+      </p:sp>
+      <p:sp>
+        <p:nvSpPr>
+          <p:cNvPr id="8" name="Text 4"/>
+          <p:cNvSpPr/>
+          <p:nvPr/>
+        </p:nvSpPr>
+        <p:spPr>
+          <a:xfrm>
+            <a:off x="2011680" y="182880"/>
+            <a:ext cx="8138160" cy="502920"/>
+          </a:xfrm>
+          <a:prstGeom prst="rect">
+            <a:avLst/>
+          </a:prstGeom>
+          <a:noFill/>
+          <a:ln/>
+        </p:spPr>
+        <p:txBody>
+          <a:bodyPr wrap="square" lIns="0" tIns="0" rIns="0" bIns="0" rtlCol="0" anchor="ctr"/>
+          <a:lstStyle/>
+          <a:p>
+            <a:pPr marL="0" indent="0" algn="ctr">
+              <a:buNone/>
+            </a:pPr>
+            <a:r>
+              <a:rPr lang="en-US" sz="2200" b="1">
+                <a:solidFill>
+                  <a:srgbClr val="1976D2"/>
+                </a:solidFill>
+                <a:latin typeface="Calibri" pitchFamily="34" charset="0"/>
+                <a:ea typeface="Calibri" pitchFamily="34" charset="-122"/>
+                <a:cs typeface="Calibri" pitchFamily="34" charset="-120"/>
+              </a:rPr>
+              <a:t>Bukti 9a | Git memeriksa file rahasia</a:t>
+            </a:r>
+            <a:endParaRPr lang="en-US" sz="2200" dirty="0"/>
+          </a:p>
+        </p:txBody>
+      </p:sp>
+      <p:sp>
+        <p:nvSpPr>
+          <p:cNvPr id="9" name="Text 5"/>
+          <p:cNvSpPr/>
+          <p:nvPr/>
+        </p:nvSpPr>
+        <p:spPr>
+          <a:xfrm>
+            <a:off x="457200" y="960120"/>
+            <a:ext cx="11247120" cy="320040"/>
+          </a:xfrm>
+          <a:prstGeom prst="rect">
+            <a:avLst/>
+          </a:prstGeom>
+          <a:noFill/>
+          <a:ln/>
+        </p:spPr>
+        <p:txBody>
+          <a:bodyPr wrap="square" lIns="0" tIns="0" rIns="0" bIns="0" rtlCol="0" anchor="ctr"/>
+          <a:lstStyle/>
+          <a:p>
+            <a:pPr marL="0" indent="0" algn="ctr">
+              <a:buNone/>
+            </a:pPr>
+            <a:r>
+              <a:rPr lang="es-ES" sz="1200" i="1">
+                <a:solidFill>
+                  <a:srgbClr val="64748B"/>
+                </a:solidFill>
+                <a:latin typeface="Calibri" pitchFamily="34" charset="0"/>
+                <a:ea typeface="Calibri" pitchFamily="34" charset="-122"/>
+                <a:cs typeface="Calibri" pitchFamily="34" charset="-120"/>
+              </a:rPr>
+              <a:t>Pemeriksaan sebelum commit laporan mahasiswa</a:t>
+            </a:r>
+            <a:endParaRPr lang="en-US" sz="1200" dirty="0"/>
+          </a:p>
+        </p:txBody>
+      </p:sp>
+      <p:pic>
+        <p:nvPicPr>
+          <p:cNvPr id="10" name="Picture 9" descr="11_git_aman.png"/>
+          <p:cNvPicPr>
+            <a:picLocks noChangeAspect="1"/>
+          </p:cNvPicPr>
+          <p:nvPr/>
+        </p:nvPicPr>
+        <p:blipFill>
+          <a:blip r:embed="rId4"/>
+          <a:stretch>
+            <a:fillRect/>
+          </a:stretch>
+        </p:blipFill>
+        <p:spPr>
+          <a:xfrm>
+            <a:off x="1525442" y="1463040"/>
+            <a:ext cx="9156356" cy="4343400"/>
+          </a:xfrm>
+          <a:prstGeom prst="rect">
+            <a:avLst/>
+          </a:prstGeom>
+        </p:spPr>
+      </p:pic>
+      <p:sp>
+        <p:nvSpPr>
+          <p:cNvPr id="11" name="TextBox 10"/>
+          <p:cNvSpPr txBox="1"/>
+          <p:nvPr/>
+        </p:nvSpPr>
+        <p:spPr>
+          <a:xfrm>
+            <a:off x="685800" y="5797296"/>
+            <a:ext cx="10881360" cy="566928"/>
+          </a:xfrm>
+          <a:prstGeom prst="rect">
+            <a:avLst/>
+          </a:prstGeom>
+          <a:noFill/>
+        </p:spPr>
+        <p:txBody>
+          <a:bodyPr wrap="square">
+            <a:spAutoFit/>
+          </a:bodyPr>
+          <a:lstStyle/>
+          <a:p>
+            <a:pPr>
+              <a:defRPr sz="1400">
+                <a:solidFill>
+                  <a:srgbClr val="0F336F"/>
+                </a:solidFill>
+                <a:latin typeface="Arial"/>
+              </a:defRPr>
+            </a:pPr>
+            <a:r>
+              <a:t>Perintah: git check-ignore -v .env secrets/db_password.txt. Fungsi: cek secret.</a:t>
+            </a:r>
+            <a:br/>
+            <a:r>
+              <a:t>Cara kerja: .gitignore menyaring keduanya; hasil: file tidak ikut commit.</a:t>
+            </a:r>
+          </a:p>
+        </p:txBody>
+      </p:sp>
+    </p:spTree>
+  </p:cSld>
+  <p:clrMapOvr>
+    <a:masterClrMapping/>
+  </p:clrMapOvr>
+</p:sld>
+</file>
+
+<file path=ppt/slides/slide22.xml><?xml version="1.0" encoding="utf-8"?>
+<p:sld xmlns:a="http://schemas.openxmlformats.org/drawingml/2006/main" xmlns:p="http://schemas.openxmlformats.org/presentationml/2006/main" xmlns:r="http://schemas.openxmlformats.org/officeDocument/2006/relationships">
+  <p:cSld>
+    <p:spTree>
+      <p:nvGrpSpPr>
+        <p:cNvPr id="1" name=""/>
+        <p:cNvGrpSpPr/>
+        <p:nvPr/>
+      </p:nvGrpSpPr>
+      <p:grpSpPr/>
+      <p:sp>
+        <p:nvSpPr>
+          <p:cNvPr id="2" name="Text 0"/>
+          <p:cNvSpPr/>
+          <p:nvPr/>
+        </p:nvSpPr>
+        <p:spPr>
+          <a:xfrm>
+            <a:off x="457200" y="6492240"/>
+            <a:ext cx="7315200" cy="274320"/>
+          </a:xfrm>
+          <a:prstGeom prst="rect">
+            <a:avLst/>
+          </a:prstGeom>
+          <a:noFill/>
+          <a:ln/>
+        </p:spPr>
+        <p:txBody>
+          <a:bodyPr wrap="square" lIns="0" tIns="0" rIns="0" bIns="0" rtlCol="0" anchor="ctr"/>
+          <a:lstStyle/>
+          <a:p>
+            <a:pPr marL="0" indent="0" algn="l">
+              <a:buNone/>
+            </a:pPr>
+            <a:r>
+              <a:rPr lang="en-US" sz="900" dirty="0">
+                <a:solidFill>
+                  <a:srgbClr val="64748B"/>
+                </a:solidFill>
+                <a:latin typeface="Calibri" pitchFamily="34" charset="0"/>
+                <a:ea typeface="Calibri" pitchFamily="34" charset="-122"/>
+                <a:cs typeface="Calibri" pitchFamily="34" charset="-120"/>
+              </a:rPr>
+              <a:t>BINUS UNIVERSITY  |  Cloud Services  |  Praktikum 7</a:t>
+            </a:r>
+            <a:endParaRPr lang="en-US" sz="900" dirty="0"/>
+          </a:p>
+        </p:txBody>
+      </p:sp>
+      <p:sp>
+        <p:nvSpPr>
+          <p:cNvPr id="3" name="Text 1"/>
+          <p:cNvSpPr/>
+          <p:nvPr/>
+        </p:nvSpPr>
+        <p:spPr>
+          <a:xfrm>
+            <a:off x="11247120" y="6492240"/>
+            <a:ext cx="457200" cy="274320"/>
+          </a:xfrm>
+          <a:prstGeom prst="rect">
+            <a:avLst/>
+          </a:prstGeom>
+          <a:noFill/>
+          <a:ln/>
+        </p:spPr>
+        <p:txBody>
+          <a:bodyPr wrap="square" lIns="0" tIns="0" rIns="0" bIns="0" rtlCol="0" anchor="ctr"/>
+          <a:lstStyle/>
+          <a:p>
+            <a:pPr marL="0" indent="0" algn="r">
+              <a:buNone/>
+            </a:pPr>
+            <a:r>
+              <a:rPr lang="en-US" sz="900" b="1">
+                <a:solidFill>
+                  <a:srgbClr val="64748B"/>
+                </a:solidFill>
+                <a:latin typeface="Calibri" pitchFamily="34" charset="0"/>
+                <a:ea typeface="Calibri" pitchFamily="34" charset="-122"/>
+                <a:cs typeface="Calibri" pitchFamily="34" charset="-120"/>
+              </a:rPr>
+              <a:t>22</a:t>
+            </a:r>
+            <a:endParaRPr lang="en-US" sz="900" dirty="0"/>
+          </a:p>
+        </p:txBody>
+      </p:sp>
+      <p:sp>
+        <p:nvSpPr>
+          <p:cNvPr id="4" name="Shape 2"/>
+          <p:cNvSpPr/>
+          <p:nvPr/>
+        </p:nvSpPr>
+        <p:spPr>
+          <a:xfrm>
+            <a:off x="457200" y="6446520"/>
+            <a:ext cx="228600" cy="36576"/>
+          </a:xfrm>
+          <a:prstGeom prst="rect">
+            <a:avLst/>
+          </a:prstGeom>
+          <a:solidFill>
+            <a:srgbClr val="F37021"/>
+          </a:solidFill>
+          <a:ln w="12700">
+            <a:solidFill>
+              <a:srgbClr val="F37021"/>
+            </a:solidFill>
+            <a:prstDash val="solid"/>
+          </a:ln>
+        </p:spPr>
+      </p:sp>
+      <p:pic>
+        <p:nvPicPr>
+          <p:cNvPr id="5" name="Picture 4" descr="image.png"/>
+          <p:cNvPicPr>
+            <a:picLocks noChangeAspect="1"/>
+          </p:cNvPicPr>
+          <p:nvPr/>
+        </p:nvPicPr>
+        <p:blipFill>
+          <a:blip r:embed="rId2"/>
+          <a:stretch>
+            <a:fillRect/>
+          </a:stretch>
+        </p:blipFill>
+        <p:spPr>
+          <a:xfrm>
+            <a:off x="274320" y="164592"/>
+            <a:ext cx="914400" cy="603504"/>
+          </a:xfrm>
+          <a:prstGeom prst="rect">
+            <a:avLst/>
+          </a:prstGeom>
+        </p:spPr>
+      </p:pic>
+      <p:pic>
+        <p:nvPicPr>
+          <p:cNvPr id="6" name="Picture 5" descr="image.png"/>
+          <p:cNvPicPr>
+            <a:picLocks noChangeAspect="1"/>
+          </p:cNvPicPr>
+          <p:nvPr/>
+        </p:nvPicPr>
+        <p:blipFill>
+          <a:blip r:embed="rId3"/>
+          <a:stretch>
+            <a:fillRect/>
+          </a:stretch>
+        </p:blipFill>
+        <p:spPr>
+          <a:xfrm>
+            <a:off x="10881360" y="182880"/>
+            <a:ext cx="1005840" cy="512064"/>
+          </a:xfrm>
+          <a:prstGeom prst="rect">
+            <a:avLst/>
+          </a:prstGeom>
+        </p:spPr>
+      </p:pic>
+      <p:sp>
+        <p:nvSpPr>
+          <p:cNvPr id="7" name="Shape 3"/>
+          <p:cNvSpPr/>
+          <p:nvPr/>
+        </p:nvSpPr>
+        <p:spPr>
+          <a:xfrm>
+            <a:off x="457200" y="868680"/>
+            <a:ext cx="11247120" cy="0"/>
+          </a:xfrm>
+          <a:prstGeom prst="line">
+            <a:avLst/>
+          </a:prstGeom>
+          <a:noFill/>
+          <a:ln w="12700">
+            <a:solidFill>
+              <a:srgbClr val="E2E8F0"/>
+            </a:solidFill>
+            <a:prstDash val="solid"/>
+          </a:ln>
+        </p:spPr>
+      </p:sp>
+      <p:sp>
+        <p:nvSpPr>
+          <p:cNvPr id="8" name="Text 4"/>
+          <p:cNvSpPr/>
+          <p:nvPr/>
+        </p:nvSpPr>
+        <p:spPr>
+          <a:xfrm>
+            <a:off x="2011680" y="182880"/>
+            <a:ext cx="8138160" cy="502920"/>
+          </a:xfrm>
+          <a:prstGeom prst="rect">
+            <a:avLst/>
+          </a:prstGeom>
+          <a:noFill/>
+          <a:ln/>
+        </p:spPr>
+        <p:txBody>
+          <a:bodyPr wrap="square" lIns="0" tIns="0" rIns="0" bIns="0" rtlCol="0" anchor="ctr"/>
+          <a:lstStyle/>
+          <a:p>
+            <a:pPr marL="0" indent="0" algn="ctr">
+              <a:buNone/>
+            </a:pPr>
+            <a:r>
+              <a:rPr lang="en-US" sz="2200" b="1">
+                <a:solidFill>
+                  <a:srgbClr val="1976D2"/>
+                </a:solidFill>
+                <a:latin typeface="Calibri" pitchFamily="34" charset="0"/>
+                <a:ea typeface="Calibri" pitchFamily="34" charset="-122"/>
+                <a:cs typeface="Calibri" pitchFamily="34" charset="-120"/>
+              </a:rPr>
+              <a:t>Bukti 9b | Container berhenti aman</a:t>
+            </a:r>
+            <a:endParaRPr lang="en-US" sz="2200" dirty="0"/>
+          </a:p>
+        </p:txBody>
+      </p:sp>
+      <p:sp>
+        <p:nvSpPr>
+          <p:cNvPr id="9" name="Text 5"/>
+          <p:cNvSpPr/>
+          <p:nvPr/>
+        </p:nvSpPr>
+        <p:spPr>
+          <a:xfrm>
+            <a:off x="457200" y="960120"/>
+            <a:ext cx="11247120" cy="320040"/>
+          </a:xfrm>
+          <a:prstGeom prst="rect">
+            <a:avLst/>
+          </a:prstGeom>
+          <a:noFill/>
+          <a:ln/>
+        </p:spPr>
+        <p:txBody>
+          <a:bodyPr wrap="square" lIns="0" tIns="0" rIns="0" bIns="0" rtlCol="0" anchor="ctr"/>
+          <a:lstStyle/>
+          <a:p>
+            <a:pPr marL="0" indent="0" algn="ctr">
+              <a:buNone/>
+            </a:pPr>
+            <a:r>
+              <a:rPr lang="es-ES" sz="1200" i="1">
+                <a:solidFill>
+                  <a:srgbClr val="64748B"/>
+                </a:solidFill>
+                <a:latin typeface="Calibri" pitchFamily="34" charset="0"/>
+                <a:ea typeface="Calibri" pitchFamily="34" charset="-122"/>
+                <a:cs typeface="Calibri" pitchFamily="34" charset="-120"/>
+              </a:rPr>
+              <a:t>Volume PostgreSQL tetap ada setelah Compose down</a:t>
+            </a:r>
+            <a:endParaRPr lang="en-US" sz="1200" dirty="0"/>
+          </a:p>
+        </p:txBody>
+      </p:sp>
+      <p:pic>
+        <p:nvPicPr>
+          <p:cNvPr id="10" name="Picture 9" descr="12_cleanup.png"/>
+          <p:cNvPicPr>
+            <a:picLocks noChangeAspect="1"/>
+          </p:cNvPicPr>
+          <p:nvPr/>
+        </p:nvPicPr>
+        <p:blipFill>
+          <a:blip r:embed="rId4"/>
+          <a:stretch>
+            <a:fillRect/>
+          </a:stretch>
+        </p:blipFill>
+        <p:spPr>
+          <a:xfrm>
+            <a:off x="1525442" y="1463040"/>
+            <a:ext cx="9156356" cy="4343400"/>
+          </a:xfrm>
+          <a:prstGeom prst="rect">
+            <a:avLst/>
+          </a:prstGeom>
+        </p:spPr>
+      </p:pic>
+      <p:sp>
+        <p:nvSpPr>
+          <p:cNvPr id="11" name="TextBox 10"/>
+          <p:cNvSpPr txBox="1"/>
+          <p:nvPr/>
+        </p:nvSpPr>
+        <p:spPr>
+          <a:xfrm>
+            <a:off x="685800" y="5797296"/>
+            <a:ext cx="10881360" cy="566928"/>
+          </a:xfrm>
+          <a:prstGeom prst="rect">
+            <a:avLst/>
+          </a:prstGeom>
+          <a:noFill/>
+        </p:spPr>
+        <p:txBody>
+          <a:bodyPr wrap="square">
+            <a:spAutoFit/>
+          </a:bodyPr>
+          <a:lstStyle/>
+          <a:p>
+            <a:pPr>
+              <a:defRPr sz="1400">
+                <a:solidFill>
+                  <a:srgbClr val="0F336F"/>
+                </a:solidFill>
+                <a:latin typeface="Arial"/>
+              </a:defRPr>
+            </a:pPr>
+            <a:r>
+              <a:t>Perintah: docker compose --profile debug down; ps. Fungsi: tutup lab.</a:t>
+            </a:r>
+            <a:br/>
+            <a:r>
+              <a:t>Cara kerja: tanpa -v, volume tetap ada; hasil: container berhenti dan ps kosong.</a:t>
+            </a:r>
+          </a:p>
+        </p:txBody>
+      </p:sp>
+    </p:spTree>
   </p:cSld>
   <p:clrMapOvr>
     <a:masterClrMapping/>

</xml_diff>

<commit_message>
Align Lab 07 with group project and publish revised theory/practical slides
</commit_message>
<xml_diff>
--- a/slides/LAB07_RLS_pgvector_Bukti_Live.pptx
+++ b/slides/LAB07_RLS_pgvector_Bukti_Live.pptx
@@ -2,34 +2,34 @@
 <file path=ppt/presentation.xml><?xml version="1.0" encoding="utf-8"?>
 <p:presentation xmlns:p="http://schemas.openxmlformats.org/presentationml/2006/main">
   <p:sldMasterIdLst>
-    <p:sldMasterId xmlns:r="http://schemas.openxmlformats.org/officeDocument/2006/relationships" id="2147483648" r:id="R3adf970a57ee4744"/>
+    <p:sldMasterId xmlns:r="http://schemas.openxmlformats.org/officeDocument/2006/relationships" id="2147483648" r:id="R9e34f9c1fc814b24"/>
   </p:sldMasterIdLst>
   <p:notesMasterIdLst>
-    <p:notesMasterId xmlns:r="http://schemas.openxmlformats.org/officeDocument/2006/relationships" r:id="Red0f49f7ecd7402e"/>
+    <p:notesMasterId xmlns:r="http://schemas.openxmlformats.org/officeDocument/2006/relationships" r:id="R89c5bc6518be4061"/>
   </p:notesMasterIdLst>
   <p:sldIdLst>
-    <p:sldId xmlns:r="http://schemas.openxmlformats.org/officeDocument/2006/relationships" id="256" r:id="R8db52b8431954b98"/>
-    <p:sldId xmlns:r="http://schemas.openxmlformats.org/officeDocument/2006/relationships" id="257" r:id="Re962ec54cef14f21"/>
-    <p:sldId xmlns:r="http://schemas.openxmlformats.org/officeDocument/2006/relationships" id="258" r:id="Rb300df0bdb044b75"/>
-    <p:sldId xmlns:r="http://schemas.openxmlformats.org/officeDocument/2006/relationships" id="259" r:id="R6795b6e0eed14403"/>
-    <p:sldId xmlns:r="http://schemas.openxmlformats.org/officeDocument/2006/relationships" id="260" r:id="R5c3900dc47464dd2"/>
-    <p:sldId xmlns:r="http://schemas.openxmlformats.org/officeDocument/2006/relationships" id="261" r:id="Rcb8689ce992c4558"/>
-    <p:sldId xmlns:r="http://schemas.openxmlformats.org/officeDocument/2006/relationships" id="262" r:id="R15eb570ba0364aa1"/>
-    <p:sldId xmlns:r="http://schemas.openxmlformats.org/officeDocument/2006/relationships" id="263" r:id="R48d7220a8c994227"/>
-    <p:sldId xmlns:r="http://schemas.openxmlformats.org/officeDocument/2006/relationships" id="264" r:id="Re6e847fe98ce47b2"/>
-    <p:sldId xmlns:r="http://schemas.openxmlformats.org/officeDocument/2006/relationships" id="265" r:id="R96e5e0dc791e4b40"/>
-    <p:sldId xmlns:r="http://schemas.openxmlformats.org/officeDocument/2006/relationships" id="266" r:id="R233435161687454f"/>
-    <p:sldId xmlns:r="http://schemas.openxmlformats.org/officeDocument/2006/relationships" id="267" r:id="Rc2afa07f701f4cd0"/>
-    <p:sldId xmlns:r="http://schemas.openxmlformats.org/officeDocument/2006/relationships" id="268" r:id="R66dcfa5bfe3e4345"/>
-    <p:sldId xmlns:r="http://schemas.openxmlformats.org/officeDocument/2006/relationships" id="269" r:id="Rf7039f2bc30c4770"/>
-    <p:sldId xmlns:r="http://schemas.openxmlformats.org/officeDocument/2006/relationships" id="270" r:id="R2cf0921ba0f944fe"/>
-    <p:sldId xmlns:r="http://schemas.openxmlformats.org/officeDocument/2006/relationships" id="271" r:id="R42f80dcc1c1b463d"/>
-    <p:sldId xmlns:r="http://schemas.openxmlformats.org/officeDocument/2006/relationships" id="272" r:id="R066afbb5c4e4457b"/>
-    <p:sldId xmlns:r="http://schemas.openxmlformats.org/officeDocument/2006/relationships" id="273" r:id="R814bcd905aa841f2"/>
-    <p:sldId xmlns:r="http://schemas.openxmlformats.org/officeDocument/2006/relationships" id="274" r:id="R5af2b0f08f3444ce"/>
-    <p:sldId xmlns:r="http://schemas.openxmlformats.org/officeDocument/2006/relationships" id="275" r:id="R0af9419c372a4538"/>
-    <p:sldId xmlns:r="http://schemas.openxmlformats.org/officeDocument/2006/relationships" id="276" r:id="R5d3aa6d8f3094041"/>
-    <p:sldId xmlns:r="http://schemas.openxmlformats.org/officeDocument/2006/relationships" id="277" r:id="R3d7cb3e0c27c469c"/>
+    <p:sldId xmlns:r="http://schemas.openxmlformats.org/officeDocument/2006/relationships" id="256" r:id="Rae6b73094f0a4d0a"/>
+    <p:sldId xmlns:r="http://schemas.openxmlformats.org/officeDocument/2006/relationships" id="257" r:id="Red30427fa9c3432c"/>
+    <p:sldId xmlns:r="http://schemas.openxmlformats.org/officeDocument/2006/relationships" id="258" r:id="Ra4502d2b6474421e"/>
+    <p:sldId xmlns:r="http://schemas.openxmlformats.org/officeDocument/2006/relationships" id="259" r:id="Rb55e0e83a07640cb"/>
+    <p:sldId xmlns:r="http://schemas.openxmlformats.org/officeDocument/2006/relationships" id="260" r:id="R94cffbbad6804ba3"/>
+    <p:sldId xmlns:r="http://schemas.openxmlformats.org/officeDocument/2006/relationships" id="261" r:id="R4007531959944d56"/>
+    <p:sldId xmlns:r="http://schemas.openxmlformats.org/officeDocument/2006/relationships" id="262" r:id="Raf058e3009614224"/>
+    <p:sldId xmlns:r="http://schemas.openxmlformats.org/officeDocument/2006/relationships" id="263" r:id="R3ba107764a52409a"/>
+    <p:sldId xmlns:r="http://schemas.openxmlformats.org/officeDocument/2006/relationships" id="264" r:id="R40f197ba905c4406"/>
+    <p:sldId xmlns:r="http://schemas.openxmlformats.org/officeDocument/2006/relationships" id="265" r:id="R4f6a00d518d54f88"/>
+    <p:sldId xmlns:r="http://schemas.openxmlformats.org/officeDocument/2006/relationships" id="266" r:id="Ra7c04efc4e574f84"/>
+    <p:sldId xmlns:r="http://schemas.openxmlformats.org/officeDocument/2006/relationships" id="267" r:id="Rc7f1abd3e72147b7"/>
+    <p:sldId xmlns:r="http://schemas.openxmlformats.org/officeDocument/2006/relationships" id="268" r:id="Rae881c3143d1492d"/>
+    <p:sldId xmlns:r="http://schemas.openxmlformats.org/officeDocument/2006/relationships" id="269" r:id="R9642d1e566d84271"/>
+    <p:sldId xmlns:r="http://schemas.openxmlformats.org/officeDocument/2006/relationships" id="270" r:id="R89427984edcd4cde"/>
+    <p:sldId xmlns:r="http://schemas.openxmlformats.org/officeDocument/2006/relationships" id="271" r:id="R65633634391246f9"/>
+    <p:sldId xmlns:r="http://schemas.openxmlformats.org/officeDocument/2006/relationships" id="272" r:id="Rc3307d0735a44850"/>
+    <p:sldId xmlns:r="http://schemas.openxmlformats.org/officeDocument/2006/relationships" id="273" r:id="R0864891c5e054cc3"/>
+    <p:sldId xmlns:r="http://schemas.openxmlformats.org/officeDocument/2006/relationships" id="274" r:id="R01acbec124094345"/>
+    <p:sldId xmlns:r="http://schemas.openxmlformats.org/officeDocument/2006/relationships" id="275" r:id="R11abb2fc6e3340c9"/>
+    <p:sldId xmlns:r="http://schemas.openxmlformats.org/officeDocument/2006/relationships" id="276" r:id="R697666ed1e974068"/>
+    <p:sldId xmlns:r="http://schemas.openxmlformats.org/officeDocument/2006/relationships" id="277" r:id="Rcc0e00df5fa84c87"/>
   </p:sldIdLst>
   <p:sldSz cx="12192000" cy="6858000"/>
   <p:notesSz cx="6858000" cy="9144000"/>
@@ -1980,7 +1980,7 @@
   </p:cSld>
   <p:clrMap bg1="lt1" tx1="dk1" bg2="lt2" tx2="dk2" accent1="accent1" accent2="accent2" accent3="accent3" accent4="accent4" accent5="accent5" accent6="accent6" hlink="hlink" folHlink="folHlink"/>
   <p:sldLayoutIdLst>
-    <p:sldLayoutId xmlns:r="http://schemas.openxmlformats.org/officeDocument/2006/relationships" id="2147483649" r:id="Rcdd2df3b874a4462"/>
+    <p:sldLayoutId xmlns:r="http://schemas.openxmlformats.org/officeDocument/2006/relationships" id="2147483649" r:id="R590690b94d4b4516"/>
   </p:sldLayoutIdLst>
   <p:hf sldNum="0" hdr="0" ftr="0" dt="0"/>
   <p:txStyles>
@@ -2533,7 +2533,7 @@
     <p:bg>
       <p:bgPr>
         <a:blipFill xmlns:a="http://schemas.openxmlformats.org/drawingml/2006/main" rotWithShape="1">
-          <a:blip xmlns:r="http://schemas.openxmlformats.org/officeDocument/2006/relationships" r:embed="Rdf2a382042d34344">
+          <a:blip xmlns:r="http://schemas.openxmlformats.org/officeDocument/2006/relationships" r:embed="Rdaa329d7239944e7">
             <a:lum/>
           </a:blip>
           <a:srcRect l="0" t="0" r="0" b="0"/>
@@ -2561,7 +2561,7 @@
           <p:nvPr/>
         </p:nvPicPr>
         <p:blipFill>
-          <a:blip xmlns:r="http://schemas.openxmlformats.org/officeDocument/2006/relationships" xmlns:a="http://schemas.openxmlformats.org/drawingml/2006/main" r:embed="R98feb3fc00394889"/>
+          <a:blip xmlns:r="http://schemas.openxmlformats.org/officeDocument/2006/relationships" xmlns:a="http://schemas.openxmlformats.org/drawingml/2006/main" r:embed="Rf4591a8f00dd4115"/>
           <a:stretch xmlns:a="http://schemas.openxmlformats.org/drawingml/2006/main">
             <a:fillRect l="0" t="0" r="0" b="0"/>
           </a:stretch>
@@ -2585,7 +2585,7 @@
           <p:nvPr/>
         </p:nvPicPr>
         <p:blipFill>
-          <a:blip xmlns:r="http://schemas.openxmlformats.org/officeDocument/2006/relationships" xmlns:a="http://schemas.openxmlformats.org/drawingml/2006/main" r:embed="Ra612411b51c34acc"/>
+          <a:blip xmlns:r="http://schemas.openxmlformats.org/officeDocument/2006/relationships" xmlns:a="http://schemas.openxmlformats.org/drawingml/2006/main" r:embed="R19ec10aaec33481d"/>
           <a:stretch xmlns:a="http://schemas.openxmlformats.org/drawingml/2006/main">
             <a:fillRect l="0" t="0" r="0" b="0"/>
           </a:stretch>
@@ -3118,7 +3118,7 @@
           <p:nvPr/>
         </p:nvPicPr>
         <p:blipFill>
-          <a:blip xmlns:r="http://schemas.openxmlformats.org/officeDocument/2006/relationships" xmlns:a="http://schemas.openxmlformats.org/drawingml/2006/main" r:embed="R271725b9483d4bd1"/>
+          <a:blip xmlns:r="http://schemas.openxmlformats.org/officeDocument/2006/relationships" xmlns:a="http://schemas.openxmlformats.org/drawingml/2006/main" r:embed="R28c9e899f9044a57"/>
           <a:stretch xmlns:a="http://schemas.openxmlformats.org/drawingml/2006/main">
             <a:fillRect l="0" t="0" r="0" b="0"/>
           </a:stretch>
@@ -3142,7 +3142,7 @@
           <p:nvPr/>
         </p:nvPicPr>
         <p:blipFill>
-          <a:blip xmlns:r="http://schemas.openxmlformats.org/officeDocument/2006/relationships" xmlns:a="http://schemas.openxmlformats.org/drawingml/2006/main" r:embed="R28374bdf5be84082"/>
+          <a:blip xmlns:r="http://schemas.openxmlformats.org/officeDocument/2006/relationships" xmlns:a="http://schemas.openxmlformats.org/drawingml/2006/main" r:embed="Rb22e9597c8b14515"/>
           <a:stretch xmlns:a="http://schemas.openxmlformats.org/drawingml/2006/main">
             <a:fillRect l="0" t="0" r="0" b="0"/>
           </a:stretch>
@@ -3717,7 +3717,7 @@
           <p:nvPr/>
         </p:nvPicPr>
         <p:blipFill>
-          <a:blip xmlns:r="http://schemas.openxmlformats.org/officeDocument/2006/relationships" xmlns:a="http://schemas.openxmlformats.org/drawingml/2006/main" r:embed="R54335a91aa7e4486"/>
+          <a:blip xmlns:r="http://schemas.openxmlformats.org/officeDocument/2006/relationships" xmlns:a="http://schemas.openxmlformats.org/drawingml/2006/main" r:embed="Rb294c309b8e1410b"/>
           <a:stretch xmlns:a="http://schemas.openxmlformats.org/drawingml/2006/main">
             <a:fillRect l="0" t="0" r="0" b="0"/>
           </a:stretch>
@@ -3741,7 +3741,7 @@
           <p:nvPr/>
         </p:nvPicPr>
         <p:blipFill>
-          <a:blip xmlns:r="http://schemas.openxmlformats.org/officeDocument/2006/relationships" xmlns:a="http://schemas.openxmlformats.org/drawingml/2006/main" r:embed="R3b351c31b5a442c8"/>
+          <a:blip xmlns:r="http://schemas.openxmlformats.org/officeDocument/2006/relationships" xmlns:a="http://schemas.openxmlformats.org/drawingml/2006/main" r:embed="R1dd4de4fc6e84fda"/>
           <a:stretch xmlns:a="http://schemas.openxmlformats.org/drawingml/2006/main">
             <a:fillRect l="0" t="0" r="0" b="0"/>
           </a:stretch>
@@ -4367,7 +4367,7 @@
           <p:nvPr/>
         </p:nvPicPr>
         <p:blipFill>
-          <a:blip xmlns:r="http://schemas.openxmlformats.org/officeDocument/2006/relationships" xmlns:a="http://schemas.openxmlformats.org/drawingml/2006/main" r:embed="Rce14d786f7644d71"/>
+          <a:blip xmlns:r="http://schemas.openxmlformats.org/officeDocument/2006/relationships" xmlns:a="http://schemas.openxmlformats.org/drawingml/2006/main" r:embed="Rf90e8ed6ec8d4a54"/>
           <a:stretch xmlns:a="http://schemas.openxmlformats.org/drawingml/2006/main">
             <a:fillRect l="0" t="0" r="0" b="0"/>
           </a:stretch>
@@ -4631,7 +4631,7 @@
           <p:nvPr/>
         </p:nvPicPr>
         <p:blipFill>
-          <a:blip xmlns:r="http://schemas.openxmlformats.org/officeDocument/2006/relationships" xmlns:a="http://schemas.openxmlformats.org/drawingml/2006/main" r:embed="Rb54a5e071c084f78"/>
+          <a:blip xmlns:r="http://schemas.openxmlformats.org/officeDocument/2006/relationships" xmlns:a="http://schemas.openxmlformats.org/drawingml/2006/main" r:embed="R893ac8b560fd4a55"/>
           <a:stretch xmlns:a="http://schemas.openxmlformats.org/drawingml/2006/main">
             <a:fillRect l="0" t="0" r="0" b="0"/>
           </a:stretch>
@@ -4655,7 +4655,7 @@
           <p:nvPr/>
         </p:nvPicPr>
         <p:blipFill>
-          <a:blip xmlns:r="http://schemas.openxmlformats.org/officeDocument/2006/relationships" xmlns:a="http://schemas.openxmlformats.org/drawingml/2006/main" r:embed="Rec695a838eec4e31"/>
+          <a:blip xmlns:r="http://schemas.openxmlformats.org/officeDocument/2006/relationships" xmlns:a="http://schemas.openxmlformats.org/drawingml/2006/main" r:embed="R47ea1d704504445d"/>
           <a:stretch xmlns:a="http://schemas.openxmlformats.org/drawingml/2006/main">
             <a:fillRect l="0" t="0" r="0" b="0"/>
           </a:stretch>
@@ -5232,7 +5232,7 @@
           <p:nvPr/>
         </p:nvPicPr>
         <p:blipFill>
-          <a:blip xmlns:r="http://schemas.openxmlformats.org/officeDocument/2006/relationships" xmlns:a="http://schemas.openxmlformats.org/drawingml/2006/main" r:embed="R06232a613fc94858"/>
+          <a:blip xmlns:r="http://schemas.openxmlformats.org/officeDocument/2006/relationships" xmlns:a="http://schemas.openxmlformats.org/drawingml/2006/main" r:embed="R835cf52cedb64fb5"/>
           <a:stretch xmlns:a="http://schemas.openxmlformats.org/drawingml/2006/main">
             <a:fillRect l="0" t="0" r="0" b="0"/>
           </a:stretch>
@@ -5256,7 +5256,7 @@
           <p:nvPr/>
         </p:nvPicPr>
         <p:blipFill>
-          <a:blip xmlns:r="http://schemas.openxmlformats.org/officeDocument/2006/relationships" xmlns:a="http://schemas.openxmlformats.org/drawingml/2006/main" r:embed="R0bb234f6d83641a6"/>
+          <a:blip xmlns:r="http://schemas.openxmlformats.org/officeDocument/2006/relationships" xmlns:a="http://schemas.openxmlformats.org/drawingml/2006/main" r:embed="R3a2258fb09334b18"/>
           <a:stretch xmlns:a="http://schemas.openxmlformats.org/drawingml/2006/main">
             <a:fillRect l="0" t="0" r="0" b="0"/>
           </a:stretch>
@@ -5882,7 +5882,7 @@
           <p:nvPr/>
         </p:nvPicPr>
         <p:blipFill>
-          <a:blip xmlns:r="http://schemas.openxmlformats.org/officeDocument/2006/relationships" xmlns:a="http://schemas.openxmlformats.org/drawingml/2006/main" r:embed="R8b81fbdc03424405"/>
+          <a:blip xmlns:r="http://schemas.openxmlformats.org/officeDocument/2006/relationships" xmlns:a="http://schemas.openxmlformats.org/drawingml/2006/main" r:embed="R1dfc808f68594ede"/>
           <a:stretch xmlns:a="http://schemas.openxmlformats.org/drawingml/2006/main">
             <a:fillRect l="0" t="0" r="0" b="0"/>
           </a:stretch>
@@ -6146,7 +6146,7 @@
           <p:nvPr/>
         </p:nvPicPr>
         <p:blipFill>
-          <a:blip xmlns:r="http://schemas.openxmlformats.org/officeDocument/2006/relationships" xmlns:a="http://schemas.openxmlformats.org/drawingml/2006/main" r:embed="Rdcf603d1811a412e"/>
+          <a:blip xmlns:r="http://schemas.openxmlformats.org/officeDocument/2006/relationships" xmlns:a="http://schemas.openxmlformats.org/drawingml/2006/main" r:embed="Rf2cf174356514452"/>
           <a:stretch xmlns:a="http://schemas.openxmlformats.org/drawingml/2006/main">
             <a:fillRect l="0" t="0" r="0" b="0"/>
           </a:stretch>
@@ -6170,7 +6170,7 @@
           <p:nvPr/>
         </p:nvPicPr>
         <p:blipFill>
-          <a:blip xmlns:r="http://schemas.openxmlformats.org/officeDocument/2006/relationships" xmlns:a="http://schemas.openxmlformats.org/drawingml/2006/main" r:embed="Re37bd4991046469f"/>
+          <a:blip xmlns:r="http://schemas.openxmlformats.org/officeDocument/2006/relationships" xmlns:a="http://schemas.openxmlformats.org/drawingml/2006/main" r:embed="R36bd88825f754461"/>
           <a:stretch xmlns:a="http://schemas.openxmlformats.org/drawingml/2006/main">
             <a:fillRect l="0" t="0" r="0" b="0"/>
           </a:stretch>
@@ -6746,7 +6746,7 @@
           <p:nvPr/>
         </p:nvPicPr>
         <p:blipFill>
-          <a:blip xmlns:r="http://schemas.openxmlformats.org/officeDocument/2006/relationships" xmlns:a="http://schemas.openxmlformats.org/drawingml/2006/main" r:embed="R657ff7e8feba464e"/>
+          <a:blip xmlns:r="http://schemas.openxmlformats.org/officeDocument/2006/relationships" xmlns:a="http://schemas.openxmlformats.org/drawingml/2006/main" r:embed="R4d368eeb200c44dc"/>
           <a:stretch xmlns:a="http://schemas.openxmlformats.org/drawingml/2006/main">
             <a:fillRect l="0" t="0" r="0" b="0"/>
           </a:stretch>
@@ -6770,7 +6770,7 @@
           <p:nvPr/>
         </p:nvPicPr>
         <p:blipFill>
-          <a:blip xmlns:r="http://schemas.openxmlformats.org/officeDocument/2006/relationships" xmlns:a="http://schemas.openxmlformats.org/drawingml/2006/main" r:embed="R388a0a17c712468c"/>
+          <a:blip xmlns:r="http://schemas.openxmlformats.org/officeDocument/2006/relationships" xmlns:a="http://schemas.openxmlformats.org/drawingml/2006/main" r:embed="R2246bfebe80246ed"/>
           <a:stretch xmlns:a="http://schemas.openxmlformats.org/drawingml/2006/main">
             <a:fillRect l="0" t="0" r="0" b="0"/>
           </a:stretch>
@@ -6996,7 +6996,7 @@
           <p:nvPr/>
         </p:nvPicPr>
         <p:blipFill>
-          <a:blip xmlns:r="http://schemas.openxmlformats.org/officeDocument/2006/relationships" xmlns:a="http://schemas.openxmlformats.org/drawingml/2006/main" r:embed="R1a57407c918142b2"/>
+          <a:blip xmlns:r="http://schemas.openxmlformats.org/officeDocument/2006/relationships" xmlns:a="http://schemas.openxmlformats.org/drawingml/2006/main" r:embed="Rf7d45ec45562404a"/>
           <a:stretch xmlns:a="http://schemas.openxmlformats.org/drawingml/2006/main">
             <a:fillRect l="0" t="0" r="0" b="0"/>
           </a:stretch>
@@ -7073,7 +7073,7 @@
           <p:nvPr/>
         </p:nvPicPr>
         <p:blipFill>
-          <a:blip xmlns:r="http://schemas.openxmlformats.org/officeDocument/2006/relationships" xmlns:a="http://schemas.openxmlformats.org/drawingml/2006/main" r:embed="Re01e1f1e6beb4829"/>
+          <a:blip xmlns:r="http://schemas.openxmlformats.org/officeDocument/2006/relationships" xmlns:a="http://schemas.openxmlformats.org/drawingml/2006/main" r:embed="Rdc230e498ebc4f42"/>
           <a:stretch xmlns:a="http://schemas.openxmlformats.org/drawingml/2006/main">
             <a:fillRect l="0" t="0" r="0" b="0"/>
           </a:stretch>
@@ -7150,7 +7150,7 @@
           <p:nvPr/>
         </p:nvPicPr>
         <p:blipFill>
-          <a:blip xmlns:r="http://schemas.openxmlformats.org/officeDocument/2006/relationships" xmlns:a="http://schemas.openxmlformats.org/drawingml/2006/main" r:embed="R6a2d75e6492a4fc9"/>
+          <a:blip xmlns:r="http://schemas.openxmlformats.org/officeDocument/2006/relationships" xmlns:a="http://schemas.openxmlformats.org/drawingml/2006/main" r:embed="Rf5a369b2f29248cc"/>
           <a:stretch xmlns:a="http://schemas.openxmlformats.org/drawingml/2006/main">
             <a:fillRect l="0" t="0" r="0" b="0"/>
           </a:stretch>
@@ -7227,7 +7227,7 @@
           <p:nvPr/>
         </p:nvPicPr>
         <p:blipFill>
-          <a:blip xmlns:r="http://schemas.openxmlformats.org/officeDocument/2006/relationships" xmlns:a="http://schemas.openxmlformats.org/drawingml/2006/main" r:embed="Rc9a7f5a165284196"/>
+          <a:blip xmlns:r="http://schemas.openxmlformats.org/officeDocument/2006/relationships" xmlns:a="http://schemas.openxmlformats.org/drawingml/2006/main" r:embed="Re75f92bcb58b477c"/>
           <a:stretch xmlns:a="http://schemas.openxmlformats.org/drawingml/2006/main">
             <a:fillRect l="0" t="0" r="0" b="0"/>
           </a:stretch>
@@ -7304,7 +7304,7 @@
           <p:nvPr/>
         </p:nvPicPr>
         <p:blipFill>
-          <a:blip xmlns:r="http://schemas.openxmlformats.org/officeDocument/2006/relationships" xmlns:a="http://schemas.openxmlformats.org/drawingml/2006/main" r:embed="R2f974e698def4772"/>
+          <a:blip xmlns:r="http://schemas.openxmlformats.org/officeDocument/2006/relationships" xmlns:a="http://schemas.openxmlformats.org/drawingml/2006/main" r:embed="Rce183b60c9f84f20"/>
           <a:stretch xmlns:a="http://schemas.openxmlformats.org/drawingml/2006/main">
             <a:fillRect l="0" t="0" r="0" b="0"/>
           </a:stretch>
@@ -7381,7 +7381,7 @@
           <p:nvPr/>
         </p:nvPicPr>
         <p:blipFill>
-          <a:blip xmlns:r="http://schemas.openxmlformats.org/officeDocument/2006/relationships" xmlns:a="http://schemas.openxmlformats.org/drawingml/2006/main" r:embed="R5dfaafa80dc241a4"/>
+          <a:blip xmlns:r="http://schemas.openxmlformats.org/officeDocument/2006/relationships" xmlns:a="http://schemas.openxmlformats.org/drawingml/2006/main" r:embed="R810ded2f20474e6b"/>
           <a:stretch xmlns:a="http://schemas.openxmlformats.org/drawingml/2006/main">
             <a:fillRect l="0" t="0" r="0" b="0"/>
           </a:stretch>
@@ -7458,7 +7458,7 @@
           <p:nvPr/>
         </p:nvPicPr>
         <p:blipFill>
-          <a:blip xmlns:r="http://schemas.openxmlformats.org/officeDocument/2006/relationships" xmlns:a="http://schemas.openxmlformats.org/drawingml/2006/main" r:embed="Rca321d97099c40d8"/>
+          <a:blip xmlns:r="http://schemas.openxmlformats.org/officeDocument/2006/relationships" xmlns:a="http://schemas.openxmlformats.org/drawingml/2006/main" r:embed="R6b6259a17c684820"/>
           <a:stretch xmlns:a="http://schemas.openxmlformats.org/drawingml/2006/main">
             <a:fillRect l="0" t="0" r="0" b="0"/>
           </a:stretch>
@@ -7738,7 +7738,7 @@
           <p:nvPr/>
         </p:nvPicPr>
         <p:blipFill>
-          <a:blip xmlns:r="http://schemas.openxmlformats.org/officeDocument/2006/relationships" xmlns:a="http://schemas.openxmlformats.org/drawingml/2006/main" r:embed="Reee82b98efb8415c"/>
+          <a:blip xmlns:r="http://schemas.openxmlformats.org/officeDocument/2006/relationships" xmlns:a="http://schemas.openxmlformats.org/drawingml/2006/main" r:embed="Ra31296ac767b4283"/>
           <a:stretch xmlns:a="http://schemas.openxmlformats.org/drawingml/2006/main">
             <a:fillRect l="0" t="0" r="0" b="0"/>
           </a:stretch>
@@ -7916,7 +7916,7 @@
           <p:nvPr/>
         </p:nvPicPr>
         <p:blipFill>
-          <a:blip xmlns:r="http://schemas.openxmlformats.org/officeDocument/2006/relationships" xmlns:a="http://schemas.openxmlformats.org/drawingml/2006/main" r:embed="R68dccf6097a54e7e"/>
+          <a:blip xmlns:r="http://schemas.openxmlformats.org/officeDocument/2006/relationships" xmlns:a="http://schemas.openxmlformats.org/drawingml/2006/main" r:embed="R3e47350e13844649"/>
           <a:stretch xmlns:a="http://schemas.openxmlformats.org/drawingml/2006/main">
             <a:fillRect l="0" t="0" r="0" b="0"/>
           </a:stretch>
@@ -7940,7 +7940,7 @@
           <p:nvPr/>
         </p:nvPicPr>
         <p:blipFill>
-          <a:blip xmlns:r="http://schemas.openxmlformats.org/officeDocument/2006/relationships" xmlns:a="http://schemas.openxmlformats.org/drawingml/2006/main" r:embed="Rb3861c9bff67404f"/>
+          <a:blip xmlns:r="http://schemas.openxmlformats.org/officeDocument/2006/relationships" xmlns:a="http://schemas.openxmlformats.org/drawingml/2006/main" r:embed="R179ea9168eb44ae9"/>
           <a:stretch xmlns:a="http://schemas.openxmlformats.org/drawingml/2006/main">
             <a:fillRect l="0" t="0" r="0" b="0"/>
           </a:stretch>
@@ -8514,7 +8514,7 @@
           <p:nvPr/>
         </p:nvPicPr>
         <p:blipFill>
-          <a:blip xmlns:r="http://schemas.openxmlformats.org/officeDocument/2006/relationships" xmlns:a="http://schemas.openxmlformats.org/drawingml/2006/main" r:embed="R4b4549eb6e4c478d"/>
+          <a:blip xmlns:r="http://schemas.openxmlformats.org/officeDocument/2006/relationships" xmlns:a="http://schemas.openxmlformats.org/drawingml/2006/main" r:embed="R3bc114351a26424a"/>
           <a:stretch xmlns:a="http://schemas.openxmlformats.org/drawingml/2006/main">
             <a:fillRect l="0" t="0" r="0" b="0"/>
           </a:stretch>
@@ -8538,7 +8538,7 @@
           <p:nvPr/>
         </p:nvPicPr>
         <p:blipFill>
-          <a:blip xmlns:r="http://schemas.openxmlformats.org/officeDocument/2006/relationships" xmlns:a="http://schemas.openxmlformats.org/drawingml/2006/main" r:embed="R6a8fe3ef4fe54910"/>
+          <a:blip xmlns:r="http://schemas.openxmlformats.org/officeDocument/2006/relationships" xmlns:a="http://schemas.openxmlformats.org/drawingml/2006/main" r:embed="R90c2c7355e9e4e63"/>
           <a:stretch xmlns:a="http://schemas.openxmlformats.org/drawingml/2006/main">
             <a:fillRect l="0" t="0" r="0" b="0"/>
           </a:stretch>
@@ -9164,7 +9164,7 @@
           <p:nvPr/>
         </p:nvPicPr>
         <p:blipFill>
-          <a:blip xmlns:r="http://schemas.openxmlformats.org/officeDocument/2006/relationships" xmlns:a="http://schemas.openxmlformats.org/drawingml/2006/main" r:embed="Rfc255d8512224396"/>
+          <a:blip xmlns:r="http://schemas.openxmlformats.org/officeDocument/2006/relationships" xmlns:a="http://schemas.openxmlformats.org/drawingml/2006/main" r:embed="R791ddb862aeb43b1"/>
           <a:stretch xmlns:a="http://schemas.openxmlformats.org/drawingml/2006/main">
             <a:fillRect l="0" t="0" r="0" b="0"/>
           </a:stretch>
@@ -9428,7 +9428,7 @@
           <p:nvPr/>
         </p:nvPicPr>
         <p:blipFill>
-          <a:blip xmlns:r="http://schemas.openxmlformats.org/officeDocument/2006/relationships" xmlns:a="http://schemas.openxmlformats.org/drawingml/2006/main" r:embed="R5346a5cffcca4463"/>
+          <a:blip xmlns:r="http://schemas.openxmlformats.org/officeDocument/2006/relationships" xmlns:a="http://schemas.openxmlformats.org/drawingml/2006/main" r:embed="Rba003cc1c3c4403c"/>
           <a:stretch xmlns:a="http://schemas.openxmlformats.org/drawingml/2006/main">
             <a:fillRect l="0" t="0" r="0" b="0"/>
           </a:stretch>
@@ -9452,7 +9452,7 @@
           <p:nvPr/>
         </p:nvPicPr>
         <p:blipFill>
-          <a:blip xmlns:r="http://schemas.openxmlformats.org/officeDocument/2006/relationships" xmlns:a="http://schemas.openxmlformats.org/drawingml/2006/main" r:embed="Ra3a1f0265eb44294"/>
+          <a:blip xmlns:r="http://schemas.openxmlformats.org/officeDocument/2006/relationships" xmlns:a="http://schemas.openxmlformats.org/drawingml/2006/main" r:embed="R4ee2dedc37f14e44"/>
           <a:stretch xmlns:a="http://schemas.openxmlformats.org/drawingml/2006/main">
             <a:fillRect l="0" t="0" r="0" b="0"/>
           </a:stretch>
@@ -10021,7 +10021,7 @@
           <p:nvPr/>
         </p:nvPicPr>
         <p:blipFill>
-          <a:blip xmlns:r="http://schemas.openxmlformats.org/officeDocument/2006/relationships" xmlns:a="http://schemas.openxmlformats.org/drawingml/2006/main" r:embed="Rcce2bf0d8ef9436b"/>
+          <a:blip xmlns:r="http://schemas.openxmlformats.org/officeDocument/2006/relationships" xmlns:a="http://schemas.openxmlformats.org/drawingml/2006/main" r:embed="R5ad1b34cc2bc4906"/>
           <a:stretch xmlns:a="http://schemas.openxmlformats.org/drawingml/2006/main">
             <a:fillRect l="0" t="0" r="0" b="0"/>
           </a:stretch>
@@ -10045,7 +10045,7 @@
           <p:nvPr/>
         </p:nvPicPr>
         <p:blipFill>
-          <a:blip xmlns:r="http://schemas.openxmlformats.org/officeDocument/2006/relationships" xmlns:a="http://schemas.openxmlformats.org/drawingml/2006/main" r:embed="R4e296cc15e154527"/>
+          <a:blip xmlns:r="http://schemas.openxmlformats.org/officeDocument/2006/relationships" xmlns:a="http://schemas.openxmlformats.org/drawingml/2006/main" r:embed="R2921a8ebc5644de8"/>
           <a:stretch xmlns:a="http://schemas.openxmlformats.org/drawingml/2006/main">
             <a:fillRect l="0" t="0" r="0" b="0"/>
           </a:stretch>
@@ -10192,7 +10192,7 @@
           <p:nvPr/>
         </p:nvPicPr>
         <p:blipFill>
-          <a:blip xmlns:r="http://schemas.openxmlformats.org/officeDocument/2006/relationships" xmlns:a="http://schemas.openxmlformats.org/drawingml/2006/main" r:embed="Rb6a202d67ef74d98"/>
+          <a:blip xmlns:r="http://schemas.openxmlformats.org/officeDocument/2006/relationships" xmlns:a="http://schemas.openxmlformats.org/drawingml/2006/main" r:embed="Rf91b1769db244e51"/>
           <a:stretch xmlns:a="http://schemas.openxmlformats.org/drawingml/2006/main">
             <a:fillRect l="0" t="0" r="0" b="0"/>
           </a:stretch>
@@ -10421,7 +10421,7 @@
           <p:nvPr/>
         </p:nvPicPr>
         <p:blipFill>
-          <a:blip xmlns:r="http://schemas.openxmlformats.org/officeDocument/2006/relationships" xmlns:a="http://schemas.openxmlformats.org/drawingml/2006/main" r:embed="R7f750226b21b49b9"/>
+          <a:blip xmlns:r="http://schemas.openxmlformats.org/officeDocument/2006/relationships" xmlns:a="http://schemas.openxmlformats.org/drawingml/2006/main" r:embed="R4d6757380cc94330"/>
           <a:stretch xmlns:a="http://schemas.openxmlformats.org/drawingml/2006/main">
             <a:fillRect l="0" t="0" r="0" b="0"/>
           </a:stretch>
@@ -10445,7 +10445,7 @@
           <p:nvPr/>
         </p:nvPicPr>
         <p:blipFill>
-          <a:blip xmlns:r="http://schemas.openxmlformats.org/officeDocument/2006/relationships" xmlns:a="http://schemas.openxmlformats.org/drawingml/2006/main" r:embed="Rb988b01a6b7e4036"/>
+          <a:blip xmlns:r="http://schemas.openxmlformats.org/officeDocument/2006/relationships" xmlns:a="http://schemas.openxmlformats.org/drawingml/2006/main" r:embed="Re3b6f15fab0847d3"/>
           <a:stretch xmlns:a="http://schemas.openxmlformats.org/drawingml/2006/main">
             <a:fillRect l="0" t="0" r="0" b="0"/>
           </a:stretch>
@@ -10700,7 +10700,7 @@
           <p:nvPr/>
         </p:nvPicPr>
         <p:blipFill>
-          <a:blip xmlns:r="http://schemas.openxmlformats.org/officeDocument/2006/relationships" xmlns:a="http://schemas.openxmlformats.org/drawingml/2006/main" r:embed="R6fc88841176a4cb7"/>
+          <a:blip xmlns:r="http://schemas.openxmlformats.org/officeDocument/2006/relationships" xmlns:a="http://schemas.openxmlformats.org/drawingml/2006/main" r:embed="R6d937bc90b4a46cd"/>
           <a:stretch xmlns:a="http://schemas.openxmlformats.org/drawingml/2006/main">
             <a:fillRect l="0" t="0" r="0" b="0"/>
           </a:stretch>
@@ -10770,7 +10770,7 @@
           <p:nvPr/>
         </p:nvPicPr>
         <p:blipFill>
-          <a:blip xmlns:r="http://schemas.openxmlformats.org/officeDocument/2006/relationships" xmlns:a="http://schemas.openxmlformats.org/drawingml/2006/main" r:embed="Rc660bf70ef9343a2"/>
+          <a:blip xmlns:r="http://schemas.openxmlformats.org/officeDocument/2006/relationships" xmlns:a="http://schemas.openxmlformats.org/drawingml/2006/main" r:embed="R6b91b2807edb4186"/>
           <a:stretch xmlns:a="http://schemas.openxmlformats.org/drawingml/2006/main">
             <a:fillRect l="0" t="0" r="0" b="0"/>
           </a:stretch>
@@ -10840,7 +10840,7 @@
           <p:nvPr/>
         </p:nvPicPr>
         <p:blipFill>
-          <a:blip xmlns:r="http://schemas.openxmlformats.org/officeDocument/2006/relationships" xmlns:a="http://schemas.openxmlformats.org/drawingml/2006/main" r:embed="Rcdf21cce14e74de6"/>
+          <a:blip xmlns:r="http://schemas.openxmlformats.org/officeDocument/2006/relationships" xmlns:a="http://schemas.openxmlformats.org/drawingml/2006/main" r:embed="R4867d4f5df534804"/>
           <a:stretch xmlns:a="http://schemas.openxmlformats.org/drawingml/2006/main">
             <a:fillRect l="0" t="0" r="0" b="0"/>
           </a:stretch>
@@ -10910,7 +10910,7 @@
           <p:nvPr/>
         </p:nvPicPr>
         <p:blipFill>
-          <a:blip xmlns:r="http://schemas.openxmlformats.org/officeDocument/2006/relationships" xmlns:a="http://schemas.openxmlformats.org/drawingml/2006/main" r:embed="R960064ec561043fb"/>
+          <a:blip xmlns:r="http://schemas.openxmlformats.org/officeDocument/2006/relationships" xmlns:a="http://schemas.openxmlformats.org/drawingml/2006/main" r:embed="R2686062099a44af2"/>
           <a:stretch xmlns:a="http://schemas.openxmlformats.org/drawingml/2006/main">
             <a:fillRect l="0" t="0" r="0" b="0"/>
           </a:stretch>
@@ -10980,7 +10980,7 @@
           <p:nvPr/>
         </p:nvPicPr>
         <p:blipFill>
-          <a:blip xmlns:r="http://schemas.openxmlformats.org/officeDocument/2006/relationships" xmlns:a="http://schemas.openxmlformats.org/drawingml/2006/main" r:embed="R85e0c71bf7404a92"/>
+          <a:blip xmlns:r="http://schemas.openxmlformats.org/officeDocument/2006/relationships" xmlns:a="http://schemas.openxmlformats.org/drawingml/2006/main" r:embed="R34d83dbdf6a74990"/>
           <a:stretch xmlns:a="http://schemas.openxmlformats.org/drawingml/2006/main">
             <a:fillRect l="0" t="0" r="0" b="0"/>
           </a:stretch>
@@ -11050,7 +11050,7 @@
           <p:nvPr/>
         </p:nvPicPr>
         <p:blipFill>
-          <a:blip xmlns:r="http://schemas.openxmlformats.org/officeDocument/2006/relationships" xmlns:a="http://schemas.openxmlformats.org/drawingml/2006/main" r:embed="R1e06245313e74a00"/>
+          <a:blip xmlns:r="http://schemas.openxmlformats.org/officeDocument/2006/relationships" xmlns:a="http://schemas.openxmlformats.org/drawingml/2006/main" r:embed="Rfb316b6602844a23"/>
           <a:stretch xmlns:a="http://schemas.openxmlformats.org/drawingml/2006/main">
             <a:fillRect l="0" t="0" r="0" b="0"/>
           </a:stretch>
@@ -11120,7 +11120,7 @@
           <p:nvPr/>
         </p:nvPicPr>
         <p:blipFill>
-          <a:blip xmlns:r="http://schemas.openxmlformats.org/officeDocument/2006/relationships" xmlns:a="http://schemas.openxmlformats.org/drawingml/2006/main" r:embed="R723b50b5a7f343a6"/>
+          <a:blip xmlns:r="http://schemas.openxmlformats.org/officeDocument/2006/relationships" xmlns:a="http://schemas.openxmlformats.org/drawingml/2006/main" r:embed="Rcd543d75783c4de0"/>
           <a:stretch xmlns:a="http://schemas.openxmlformats.org/drawingml/2006/main">
             <a:fillRect l="0" t="0" r="0" b="0"/>
           </a:stretch>
@@ -11254,7 +11254,7 @@
                 <a:ea typeface="Calibri"/>
                 <a:cs typeface="Calibri"/>
               </a:rPr>
-              <a:t>BUKTI YANG DIKUMPULKAN</a:t>
+              <a:t>PROYEK KELOMPOK</a:t>
             </a:r>
           </a:p>
           <a:p xmlns:a="http://schemas.openxmlformats.org/drawingml/2006/main">
@@ -11283,7 +11283,7 @@
                 <a:ea typeface="Calibri"/>
                 <a:cs typeface="Calibri"/>
               </a:rPr>
-              <a:t>Hasil mesin sendiri</a:t>
+              <a:t>Tim 3 orang</a:t>
             </a:r>
             <a:endParaRPr sz="1100"/>
           </a:p>
@@ -11332,7 +11332,7 @@
                 <a:ea typeface="Calibri"/>
                 <a:cs typeface="Calibri"/>
               </a:rPr>
-              <a:t>1. Policy RLS dan hasil dua role</a:t>
+              <a:t>RLS melindungi data tiap pengguna proyek</a:t>
             </a:r>
           </a:p>
           <a:p xmlns:a="http://schemas.openxmlformats.org/drawingml/2006/main">
@@ -11351,7 +11351,7 @@
                 <a:ea typeface="Calibri"/>
                 <a:cs typeface="Calibri"/>
               </a:rPr>
-              <a:t>2. Penolakan akses lintas pemilik</a:t>
+              <a:t>Uji dua identitas dan akses ditolak</a:t>
             </a:r>
           </a:p>
           <a:p xmlns:a="http://schemas.openxmlformats.org/drawingml/2006/main">
@@ -11370,7 +11370,7 @@
                 <a:ea typeface="Calibri"/>
                 <a:cs typeface="Calibri"/>
               </a:rPr>
-              <a:t>3. Urutan jarak pgvector</a:t>
+              <a:t>Simpan bukti bila berguna</a:t>
             </a:r>
           </a:p>
           <a:p xmlns:a="http://schemas.openxmlformats.org/drawingml/2006/main">
@@ -11389,7 +11389,7 @@
                 <a:ea typeface="Calibri"/>
                 <a:cs typeface="Calibri"/>
               </a:rPr>
-              <a:t>4. Checker 10 PASS dan commit aman</a:t>
+              <a:t>Minggu 7 dan 14; tanpa nilai Lab 07</a:t>
             </a:r>
             <a:endParaRPr sz="1700"/>
           </a:p>
@@ -11637,7 +11637,7 @@
           <p:nvPr/>
         </p:nvPicPr>
         <p:blipFill>
-          <a:blip xmlns:r="http://schemas.openxmlformats.org/officeDocument/2006/relationships" xmlns:a="http://schemas.openxmlformats.org/drawingml/2006/main" r:embed="R2c40ed182c9b4036"/>
+          <a:blip xmlns:r="http://schemas.openxmlformats.org/officeDocument/2006/relationships" xmlns:a="http://schemas.openxmlformats.org/drawingml/2006/main" r:embed="R8d1a953747b64b48"/>
           <a:stretch xmlns:a="http://schemas.openxmlformats.org/drawingml/2006/main">
             <a:fillRect l="0" t="0" r="0" b="0"/>
           </a:stretch>
@@ -11661,7 +11661,7 @@
           <p:nvPr/>
         </p:nvPicPr>
         <p:blipFill>
-          <a:blip xmlns:r="http://schemas.openxmlformats.org/officeDocument/2006/relationships" xmlns:a="http://schemas.openxmlformats.org/drawingml/2006/main" r:embed="R0dd56c9a17944f05"/>
+          <a:blip xmlns:r="http://schemas.openxmlformats.org/officeDocument/2006/relationships" xmlns:a="http://schemas.openxmlformats.org/drawingml/2006/main" r:embed="R6423e28565e94260"/>
           <a:stretch xmlns:a="http://schemas.openxmlformats.org/drawingml/2006/main">
             <a:fillRect l="0" t="0" r="0" b="0"/>
           </a:stretch>
@@ -12231,7 +12231,7 @@
           <p:nvPr/>
         </p:nvPicPr>
         <p:blipFill>
-          <a:blip xmlns:r="http://schemas.openxmlformats.org/officeDocument/2006/relationships" xmlns:a="http://schemas.openxmlformats.org/drawingml/2006/main" r:embed="Re9fcf7b6ec244034"/>
+          <a:blip xmlns:r="http://schemas.openxmlformats.org/officeDocument/2006/relationships" xmlns:a="http://schemas.openxmlformats.org/drawingml/2006/main" r:embed="Rb5d32d02cca44ed1"/>
           <a:stretch xmlns:a="http://schemas.openxmlformats.org/drawingml/2006/main">
             <a:fillRect l="0" t="0" r="0" b="0"/>
           </a:stretch>
@@ -12255,7 +12255,7 @@
           <p:nvPr/>
         </p:nvPicPr>
         <p:blipFill>
-          <a:blip xmlns:r="http://schemas.openxmlformats.org/officeDocument/2006/relationships" xmlns:a="http://schemas.openxmlformats.org/drawingml/2006/main" r:embed="R877a9c7cbcb54b43"/>
+          <a:blip xmlns:r="http://schemas.openxmlformats.org/officeDocument/2006/relationships" xmlns:a="http://schemas.openxmlformats.org/drawingml/2006/main" r:embed="R3104e69a071340e4"/>
           <a:stretch xmlns:a="http://schemas.openxmlformats.org/drawingml/2006/main">
             <a:fillRect l="0" t="0" r="0" b="0"/>
           </a:stretch>
@@ -12402,7 +12402,7 @@
           <p:nvPr/>
         </p:nvPicPr>
         <p:blipFill>
-          <a:blip xmlns:r="http://schemas.openxmlformats.org/officeDocument/2006/relationships" xmlns:a="http://schemas.openxmlformats.org/drawingml/2006/main" r:embed="Re83f315cdef84111"/>
+          <a:blip xmlns:r="http://schemas.openxmlformats.org/officeDocument/2006/relationships" xmlns:a="http://schemas.openxmlformats.org/drawingml/2006/main" r:embed="R319474101232479c"/>
           <a:stretch xmlns:a="http://schemas.openxmlformats.org/drawingml/2006/main">
             <a:fillRect l="0" t="0" r="0" b="0"/>
           </a:stretch>
@@ -12624,7 +12624,7 @@
           <p:nvPr/>
         </p:nvPicPr>
         <p:blipFill>
-          <a:blip xmlns:r="http://schemas.openxmlformats.org/officeDocument/2006/relationships" xmlns:a="http://schemas.openxmlformats.org/drawingml/2006/main" r:embed="R1cf66de13e72439c"/>
+          <a:blip xmlns:r="http://schemas.openxmlformats.org/officeDocument/2006/relationships" xmlns:a="http://schemas.openxmlformats.org/drawingml/2006/main" r:embed="R876ad0a35e9f4886"/>
           <a:stretch xmlns:a="http://schemas.openxmlformats.org/drawingml/2006/main">
             <a:fillRect l="0" t="0" r="0" b="0"/>
           </a:stretch>
@@ -12648,7 +12648,7 @@
           <p:nvPr/>
         </p:nvPicPr>
         <p:blipFill>
-          <a:blip xmlns:r="http://schemas.openxmlformats.org/officeDocument/2006/relationships" xmlns:a="http://schemas.openxmlformats.org/drawingml/2006/main" r:embed="R8189440210cf4d36"/>
+          <a:blip xmlns:r="http://schemas.openxmlformats.org/officeDocument/2006/relationships" xmlns:a="http://schemas.openxmlformats.org/drawingml/2006/main" r:embed="R57d20f9f0df443a6"/>
           <a:stretch xmlns:a="http://schemas.openxmlformats.org/drawingml/2006/main">
             <a:fillRect l="0" t="0" r="0" b="0"/>
           </a:stretch>
@@ -12795,7 +12795,7 @@
           <p:nvPr/>
         </p:nvPicPr>
         <p:blipFill>
-          <a:blip xmlns:r="http://schemas.openxmlformats.org/officeDocument/2006/relationships" xmlns:a="http://schemas.openxmlformats.org/drawingml/2006/main" r:embed="R3c56cb94734b42de"/>
+          <a:blip xmlns:r="http://schemas.openxmlformats.org/officeDocument/2006/relationships" xmlns:a="http://schemas.openxmlformats.org/drawingml/2006/main" r:embed="Rf3aa22110e044779"/>
           <a:stretch xmlns:a="http://schemas.openxmlformats.org/drawingml/2006/main">
             <a:fillRect l="0" t="0" r="0" b="0"/>
           </a:stretch>
@@ -13024,7 +13024,7 @@
           <p:nvPr/>
         </p:nvPicPr>
         <p:blipFill>
-          <a:blip xmlns:r="http://schemas.openxmlformats.org/officeDocument/2006/relationships" xmlns:a="http://schemas.openxmlformats.org/drawingml/2006/main" r:embed="Ra80ac2a234da4c62"/>
+          <a:blip xmlns:r="http://schemas.openxmlformats.org/officeDocument/2006/relationships" xmlns:a="http://schemas.openxmlformats.org/drawingml/2006/main" r:embed="R4fde0848ec4f4bfe"/>
           <a:stretch xmlns:a="http://schemas.openxmlformats.org/drawingml/2006/main">
             <a:fillRect l="0" t="0" r="0" b="0"/>
           </a:stretch>
@@ -13048,7 +13048,7 @@
           <p:nvPr/>
         </p:nvPicPr>
         <p:blipFill>
-          <a:blip xmlns:r="http://schemas.openxmlformats.org/officeDocument/2006/relationships" xmlns:a="http://schemas.openxmlformats.org/drawingml/2006/main" r:embed="Rb73c43d4fbae40fe"/>
+          <a:blip xmlns:r="http://schemas.openxmlformats.org/officeDocument/2006/relationships" xmlns:a="http://schemas.openxmlformats.org/drawingml/2006/main" r:embed="Ra4292b166baf4d01"/>
           <a:stretch xmlns:a="http://schemas.openxmlformats.org/drawingml/2006/main">
             <a:fillRect l="0" t="0" r="0" b="0"/>
           </a:stretch>
@@ -13622,7 +13622,7 @@
           <p:nvPr/>
         </p:nvPicPr>
         <p:blipFill>
-          <a:blip xmlns:r="http://schemas.openxmlformats.org/officeDocument/2006/relationships" xmlns:a="http://schemas.openxmlformats.org/drawingml/2006/main" r:embed="Ra0c76bb7925046b6"/>
+          <a:blip xmlns:r="http://schemas.openxmlformats.org/officeDocument/2006/relationships" xmlns:a="http://schemas.openxmlformats.org/drawingml/2006/main" r:embed="R86285ffb58b54325"/>
           <a:stretch xmlns:a="http://schemas.openxmlformats.org/drawingml/2006/main">
             <a:fillRect l="0" t="0" r="0" b="0"/>
           </a:stretch>
@@ -13646,7 +13646,7 @@
           <p:nvPr/>
         </p:nvPicPr>
         <p:blipFill>
-          <a:blip xmlns:r="http://schemas.openxmlformats.org/officeDocument/2006/relationships" xmlns:a="http://schemas.openxmlformats.org/drawingml/2006/main" r:embed="Rd6fee0750288477b"/>
+          <a:blip xmlns:r="http://schemas.openxmlformats.org/officeDocument/2006/relationships" xmlns:a="http://schemas.openxmlformats.org/drawingml/2006/main" r:embed="R98d1789fafc14549"/>
           <a:stretch xmlns:a="http://schemas.openxmlformats.org/drawingml/2006/main">
             <a:fillRect l="0" t="0" r="0" b="0"/>
           </a:stretch>
@@ -14272,7 +14272,7 @@
           <p:nvPr/>
         </p:nvPicPr>
         <p:blipFill>
-          <a:blip xmlns:r="http://schemas.openxmlformats.org/officeDocument/2006/relationships" xmlns:a="http://schemas.openxmlformats.org/drawingml/2006/main" r:embed="R79fb9bc70f154d10"/>
+          <a:blip xmlns:r="http://schemas.openxmlformats.org/officeDocument/2006/relationships" xmlns:a="http://schemas.openxmlformats.org/drawingml/2006/main" r:embed="Rb0cfac1937944b0c"/>
           <a:stretch xmlns:a="http://schemas.openxmlformats.org/drawingml/2006/main">
             <a:fillRect l="0" t="0" r="0" b="0"/>
           </a:stretch>
@@ -14536,7 +14536,7 @@
           <p:nvPr/>
         </p:nvPicPr>
         <p:blipFill>
-          <a:blip xmlns:r="http://schemas.openxmlformats.org/officeDocument/2006/relationships" xmlns:a="http://schemas.openxmlformats.org/drawingml/2006/main" r:embed="R0a8822a2de85462b"/>
+          <a:blip xmlns:r="http://schemas.openxmlformats.org/officeDocument/2006/relationships" xmlns:a="http://schemas.openxmlformats.org/drawingml/2006/main" r:embed="R2450bcfe187b455c"/>
           <a:stretch xmlns:a="http://schemas.openxmlformats.org/drawingml/2006/main">
             <a:fillRect l="0" t="0" r="0" b="0"/>
           </a:stretch>
@@ -14560,7 +14560,7 @@
           <p:nvPr/>
         </p:nvPicPr>
         <p:blipFill>
-          <a:blip xmlns:r="http://schemas.openxmlformats.org/officeDocument/2006/relationships" xmlns:a="http://schemas.openxmlformats.org/drawingml/2006/main" r:embed="R361c3d0aaec349bb"/>
+          <a:blip xmlns:r="http://schemas.openxmlformats.org/officeDocument/2006/relationships" xmlns:a="http://schemas.openxmlformats.org/drawingml/2006/main" r:embed="Rad6e3d25f458449f"/>
           <a:stretch xmlns:a="http://schemas.openxmlformats.org/drawingml/2006/main">
             <a:fillRect l="0" t="0" r="0" b="0"/>
           </a:stretch>
@@ -15186,7 +15186,7 @@
           <p:nvPr/>
         </p:nvPicPr>
         <p:blipFill>
-          <a:blip xmlns:r="http://schemas.openxmlformats.org/officeDocument/2006/relationships" xmlns:a="http://schemas.openxmlformats.org/drawingml/2006/main" r:embed="R18c34e1351ab4a08"/>
+          <a:blip xmlns:r="http://schemas.openxmlformats.org/officeDocument/2006/relationships" xmlns:a="http://schemas.openxmlformats.org/drawingml/2006/main" r:embed="Rbc11bbcf76ce426d"/>
           <a:stretch xmlns:a="http://schemas.openxmlformats.org/drawingml/2006/main">
             <a:fillRect l="0" t="0" r="0" b="0"/>
           </a:stretch>
@@ -15450,7 +15450,7 @@
           <p:nvPr/>
         </p:nvPicPr>
         <p:blipFill>
-          <a:blip xmlns:r="http://schemas.openxmlformats.org/officeDocument/2006/relationships" xmlns:a="http://schemas.openxmlformats.org/drawingml/2006/main" r:embed="R1525490b36704e65"/>
+          <a:blip xmlns:r="http://schemas.openxmlformats.org/officeDocument/2006/relationships" xmlns:a="http://schemas.openxmlformats.org/drawingml/2006/main" r:embed="R373fa773edb24448"/>
           <a:stretch xmlns:a="http://schemas.openxmlformats.org/drawingml/2006/main">
             <a:fillRect l="0" t="0" r="0" b="0"/>
           </a:stretch>
@@ -15474,7 +15474,7 @@
           <p:nvPr/>
         </p:nvPicPr>
         <p:blipFill>
-          <a:blip xmlns:r="http://schemas.openxmlformats.org/officeDocument/2006/relationships" xmlns:a="http://schemas.openxmlformats.org/drawingml/2006/main" r:embed="R64b88f26fc664d6c"/>
+          <a:blip xmlns:r="http://schemas.openxmlformats.org/officeDocument/2006/relationships" xmlns:a="http://schemas.openxmlformats.org/drawingml/2006/main" r:embed="Re95664c1efbe4a16"/>
           <a:stretch xmlns:a="http://schemas.openxmlformats.org/drawingml/2006/main">
             <a:fillRect l="0" t="0" r="0" b="0"/>
           </a:stretch>
@@ -16050,7 +16050,7 @@
           <p:nvPr/>
         </p:nvPicPr>
         <p:blipFill>
-          <a:blip xmlns:r="http://schemas.openxmlformats.org/officeDocument/2006/relationships" xmlns:a="http://schemas.openxmlformats.org/drawingml/2006/main" r:embed="R0b8980f17d3b4d1f"/>
+          <a:blip xmlns:r="http://schemas.openxmlformats.org/officeDocument/2006/relationships" xmlns:a="http://schemas.openxmlformats.org/drawingml/2006/main" r:embed="R102c75eece3d4d54"/>
           <a:stretch xmlns:a="http://schemas.openxmlformats.org/drawingml/2006/main">
             <a:fillRect l="0" t="0" r="0" b="0"/>
           </a:stretch>
@@ -16074,7 +16074,7 @@
           <p:nvPr/>
         </p:nvPicPr>
         <p:blipFill>
-          <a:blip xmlns:r="http://schemas.openxmlformats.org/officeDocument/2006/relationships" xmlns:a="http://schemas.openxmlformats.org/drawingml/2006/main" r:embed="R521f50abd3214ea7"/>
+          <a:blip xmlns:r="http://schemas.openxmlformats.org/officeDocument/2006/relationships" xmlns:a="http://schemas.openxmlformats.org/drawingml/2006/main" r:embed="R8e4ec09ed1414a73"/>
           <a:stretch xmlns:a="http://schemas.openxmlformats.org/drawingml/2006/main">
             <a:fillRect l="0" t="0" r="0" b="0"/>
           </a:stretch>
@@ -16700,7 +16700,7 @@
           <p:nvPr/>
         </p:nvPicPr>
         <p:blipFill>
-          <a:blip xmlns:r="http://schemas.openxmlformats.org/officeDocument/2006/relationships" xmlns:a="http://schemas.openxmlformats.org/drawingml/2006/main" r:embed="Rf0f1c51c614c4508"/>
+          <a:blip xmlns:r="http://schemas.openxmlformats.org/officeDocument/2006/relationships" xmlns:a="http://schemas.openxmlformats.org/drawingml/2006/main" r:embed="Ra311ed35e1894d92"/>
           <a:stretch xmlns:a="http://schemas.openxmlformats.org/drawingml/2006/main">
             <a:fillRect l="0" t="0" r="0" b="0"/>
           </a:stretch>
@@ -16964,7 +16964,7 @@
           <p:nvPr/>
         </p:nvPicPr>
         <p:blipFill>
-          <a:blip xmlns:r="http://schemas.openxmlformats.org/officeDocument/2006/relationships" xmlns:a="http://schemas.openxmlformats.org/drawingml/2006/main" r:embed="R495f334704cc4504"/>
+          <a:blip xmlns:r="http://schemas.openxmlformats.org/officeDocument/2006/relationships" xmlns:a="http://schemas.openxmlformats.org/drawingml/2006/main" r:embed="R63a71723a1bd47d6"/>
           <a:stretch xmlns:a="http://schemas.openxmlformats.org/drawingml/2006/main">
             <a:fillRect l="0" t="0" r="0" b="0"/>
           </a:stretch>
@@ -16988,7 +16988,7 @@
           <p:nvPr/>
         </p:nvPicPr>
         <p:blipFill>
-          <a:blip xmlns:r="http://schemas.openxmlformats.org/officeDocument/2006/relationships" xmlns:a="http://schemas.openxmlformats.org/drawingml/2006/main" r:embed="Rd670ce66e33d4cca"/>
+          <a:blip xmlns:r="http://schemas.openxmlformats.org/officeDocument/2006/relationships" xmlns:a="http://schemas.openxmlformats.org/drawingml/2006/main" r:embed="R053ef9c6c6884236"/>
           <a:stretch xmlns:a="http://schemas.openxmlformats.org/drawingml/2006/main">
             <a:fillRect l="0" t="0" r="0" b="0"/>
           </a:stretch>
@@ -17566,7 +17566,7 @@
           <p:nvPr/>
         </p:nvPicPr>
         <p:blipFill>
-          <a:blip xmlns:r="http://schemas.openxmlformats.org/officeDocument/2006/relationships" xmlns:a="http://schemas.openxmlformats.org/drawingml/2006/main" r:embed="Rce1fef9aaca4419f"/>
+          <a:blip xmlns:r="http://schemas.openxmlformats.org/officeDocument/2006/relationships" xmlns:a="http://schemas.openxmlformats.org/drawingml/2006/main" r:embed="R81396c39ac56426c"/>
           <a:stretch xmlns:a="http://schemas.openxmlformats.org/drawingml/2006/main">
             <a:fillRect l="0" t="0" r="0" b="0"/>
           </a:stretch>
@@ -17590,7 +17590,7 @@
           <p:nvPr/>
         </p:nvPicPr>
         <p:blipFill>
-          <a:blip xmlns:r="http://schemas.openxmlformats.org/officeDocument/2006/relationships" xmlns:a="http://schemas.openxmlformats.org/drawingml/2006/main" r:embed="Ree7c88f10e134e7c"/>
+          <a:blip xmlns:r="http://schemas.openxmlformats.org/officeDocument/2006/relationships" xmlns:a="http://schemas.openxmlformats.org/drawingml/2006/main" r:embed="R5c298d1479e346d4"/>
           <a:stretch xmlns:a="http://schemas.openxmlformats.org/drawingml/2006/main">
             <a:fillRect l="0" t="0" r="0" b="0"/>
           </a:stretch>
@@ -18216,7 +18216,7 @@
           <p:nvPr/>
         </p:nvPicPr>
         <p:blipFill>
-          <a:blip xmlns:r="http://schemas.openxmlformats.org/officeDocument/2006/relationships" xmlns:a="http://schemas.openxmlformats.org/drawingml/2006/main" r:embed="R1ab5dbd262ee4e7a"/>
+          <a:blip xmlns:r="http://schemas.openxmlformats.org/officeDocument/2006/relationships" xmlns:a="http://schemas.openxmlformats.org/drawingml/2006/main" r:embed="R24120b91caf94176"/>
           <a:stretch xmlns:a="http://schemas.openxmlformats.org/drawingml/2006/main">
             <a:fillRect l="0" t="0" r="0" b="0"/>
           </a:stretch>

</xml_diff>